<commit_message>
Fix broken closing and KPI slides
Three parameter-naming bugs caused slides to render incomplete:
- addClosingSlide: expects phone/web/email/rightTitle/cta,
  not actions[]/contact{}
- addKpiSlide: expects kpis[], not metrics[]
- addAgendaSlide: expects sections[], not items[]

Fixed in both generators. Re-verified all slides via python-pptx —
all content slides now have full content (closings have 16 shapes
vs 3 before; KPI has 20 vs 7; agenda has 34 vs 6).
</commit_message>
<xml_diff>
--- a/slides/aigw-course.pptx
+++ b/slides/aigw-course.pptx
@@ -6660,7 +6660,7 @@
                 <a:ea typeface="微軟正黑體" pitchFamily="34" charset="-122"/>
                 <a:cs typeface="微軟正黑體" pitchFamily="34" charset="-120"/>
               </a:rPr>
-              <a:t>感謝參與本次課程！</a:t>
+              <a:t>感謝參與</a:t>
             </a:r>
             <a:endParaRPr lang="en-US" sz="1800" dirty="0"/>
           </a:p>
@@ -6699,9 +6699,501 @@
                 <a:ea typeface="微軟正黑體" pitchFamily="34" charset="-122"/>
                 <a:cs typeface="微軟正黑體" pitchFamily="34" charset="-120"/>
               </a:rPr>
-              <a:t>Repo 在 github.com/victor80122/cloudflare-aigw-course</a:t>
+              <a:t>Thank You</a:t>
             </a:r>
             <a:endParaRPr lang="en-US" sz="2400" dirty="0"/>
+          </a:p>
+        </p:txBody>
+      </p:sp>
+      <p:sp>
+        <p:nvSpPr>
+          <p:cNvPr id="5" name="Text 3"/>
+          <p:cNvSpPr/>
+          <p:nvPr/>
+        </p:nvSpPr>
+        <p:spPr>
+          <a:xfrm>
+            <a:off x="457200" y="3200400"/>
+            <a:ext cx="365760" cy="365760"/>
+          </a:xfrm>
+          <a:prstGeom prst="rect">
+            <a:avLst/>
+          </a:prstGeom>
+          <a:noFill/>
+          <a:ln/>
+        </p:spPr>
+        <p:txBody>
+          <a:bodyPr wrap="square" rtlCol="0" anchor="ctr"/>
+          <a:lstStyle/>
+          <a:p>
+            <a:pPr indent="0" marL="0">
+              <a:buNone/>
+            </a:pPr>
+            <a:r>
+              <a:rPr lang="en-US" sz="1600" dirty="0">
+                <a:solidFill>
+                  <a:srgbClr val="FFFFFF"/>
+                </a:solidFill>
+                <a:latin typeface="微軟正黑體" pitchFamily="34" charset="0"/>
+                <a:ea typeface="微軟正黑體" pitchFamily="34" charset="-122"/>
+                <a:cs typeface="微軟正黑體" pitchFamily="34" charset="-120"/>
+              </a:rPr>
+              <a:t>☎</a:t>
+            </a:r>
+            <a:endParaRPr lang="en-US" sz="1600" dirty="0"/>
+          </a:p>
+        </p:txBody>
+      </p:sp>
+      <p:sp>
+        <p:nvSpPr>
+          <p:cNvPr id="6" name="Text 4"/>
+          <p:cNvSpPr/>
+          <p:nvPr/>
+        </p:nvSpPr>
+        <p:spPr>
+          <a:xfrm>
+            <a:off x="914400" y="3200400"/>
+            <a:ext cx="3200400" cy="365760"/>
+          </a:xfrm>
+          <a:prstGeom prst="rect">
+            <a:avLst/>
+          </a:prstGeom>
+          <a:noFill/>
+          <a:ln/>
+        </p:spPr>
+        <p:txBody>
+          <a:bodyPr wrap="square" rtlCol="0" anchor="ctr"/>
+          <a:lstStyle/>
+          <a:p>
+            <a:pPr indent="0" marL="0">
+              <a:buNone/>
+            </a:pPr>
+            <a:r>
+              <a:rPr lang="en-US" sz="1400" dirty="0">
+                <a:solidFill>
+                  <a:srgbClr val="FFFFFF"/>
+                </a:solidFill>
+                <a:latin typeface="微軟正黑體" pitchFamily="34" charset="0"/>
+                <a:ea typeface="微軟正黑體" pitchFamily="34" charset="-122"/>
+                <a:cs typeface="微軟正黑體" pitchFamily="34" charset="-120"/>
+              </a:rPr>
+              <a:t>+886-2-77220055</a:t>
+            </a:r>
+            <a:endParaRPr lang="en-US" sz="1400" dirty="0"/>
+          </a:p>
+        </p:txBody>
+      </p:sp>
+      <p:sp>
+        <p:nvSpPr>
+          <p:cNvPr id="7" name="Text 5"/>
+          <p:cNvSpPr/>
+          <p:nvPr/>
+        </p:nvSpPr>
+        <p:spPr>
+          <a:xfrm>
+            <a:off x="457200" y="3703320"/>
+            <a:ext cx="365760" cy="365760"/>
+          </a:xfrm>
+          <a:prstGeom prst="rect">
+            <a:avLst/>
+          </a:prstGeom>
+          <a:noFill/>
+          <a:ln/>
+        </p:spPr>
+        <p:txBody>
+          <a:bodyPr wrap="square" rtlCol="0" anchor="ctr"/>
+          <a:lstStyle/>
+          <a:p>
+            <a:pPr indent="0" marL="0">
+              <a:buNone/>
+            </a:pPr>
+            <a:r>
+              <a:rPr lang="en-US" sz="1600" dirty="0">
+                <a:solidFill>
+                  <a:srgbClr val="FFFFFF"/>
+                </a:solidFill>
+                <a:latin typeface="微軟正黑體" pitchFamily="34" charset="0"/>
+                <a:ea typeface="微軟正黑體" pitchFamily="34" charset="-122"/>
+                <a:cs typeface="微軟正黑體" pitchFamily="34" charset="-120"/>
+              </a:rPr>
+              <a:t>🌐</a:t>
+            </a:r>
+            <a:endParaRPr lang="en-US" sz="1600" dirty="0"/>
+          </a:p>
+        </p:txBody>
+      </p:sp>
+      <p:sp>
+        <p:nvSpPr>
+          <p:cNvPr id="8" name="Text 6"/>
+          <p:cNvSpPr/>
+          <p:nvPr/>
+        </p:nvSpPr>
+        <p:spPr>
+          <a:xfrm>
+            <a:off x="914400" y="3703320"/>
+            <a:ext cx="3200400" cy="365760"/>
+          </a:xfrm>
+          <a:prstGeom prst="rect">
+            <a:avLst/>
+          </a:prstGeom>
+          <a:noFill/>
+          <a:ln/>
+        </p:spPr>
+        <p:txBody>
+          <a:bodyPr wrap="square" rtlCol="0" anchor="ctr"/>
+          <a:lstStyle/>
+          <a:p>
+            <a:pPr indent="0" marL="0">
+              <a:buNone/>
+            </a:pPr>
+            <a:r>
+              <a:rPr lang="en-US" sz="1400" dirty="0">
+                <a:solidFill>
+                  <a:srgbClr val="FFFFFF"/>
+                </a:solidFill>
+                <a:latin typeface="微軟正黑體" pitchFamily="34" charset="0"/>
+                <a:ea typeface="微軟正黑體" pitchFamily="34" charset="-122"/>
+                <a:cs typeface="微軟正黑體" pitchFamily="34" charset="-120"/>
+              </a:rPr>
+              <a:t>www.leyun.cloud</a:t>
+            </a:r>
+            <a:endParaRPr lang="en-US" sz="1400" dirty="0"/>
+          </a:p>
+        </p:txBody>
+      </p:sp>
+      <p:sp>
+        <p:nvSpPr>
+          <p:cNvPr id="9" name="Text 7"/>
+          <p:cNvSpPr/>
+          <p:nvPr/>
+        </p:nvSpPr>
+        <p:spPr>
+          <a:xfrm>
+            <a:off x="457200" y="4206240"/>
+            <a:ext cx="365760" cy="365760"/>
+          </a:xfrm>
+          <a:prstGeom prst="rect">
+            <a:avLst/>
+          </a:prstGeom>
+          <a:noFill/>
+          <a:ln/>
+        </p:spPr>
+        <p:txBody>
+          <a:bodyPr wrap="square" rtlCol="0" anchor="ctr"/>
+          <a:lstStyle/>
+          <a:p>
+            <a:pPr indent="0" marL="0">
+              <a:buNone/>
+            </a:pPr>
+            <a:r>
+              <a:rPr lang="en-US" sz="1600" dirty="0">
+                <a:solidFill>
+                  <a:srgbClr val="FFFFFF"/>
+                </a:solidFill>
+                <a:latin typeface="微軟正黑體" pitchFamily="34" charset="0"/>
+                <a:ea typeface="微軟正黑體" pitchFamily="34" charset="-122"/>
+                <a:cs typeface="微軟正黑體" pitchFamily="34" charset="-120"/>
+              </a:rPr>
+              <a:t>✉</a:t>
+            </a:r>
+            <a:endParaRPr lang="en-US" sz="1600" dirty="0"/>
+          </a:p>
+        </p:txBody>
+      </p:sp>
+      <p:sp>
+        <p:nvSpPr>
+          <p:cNvPr id="10" name="Text 8"/>
+          <p:cNvSpPr/>
+          <p:nvPr/>
+        </p:nvSpPr>
+        <p:spPr>
+          <a:xfrm>
+            <a:off x="914400" y="4206240"/>
+            <a:ext cx="3200400" cy="365760"/>
+          </a:xfrm>
+          <a:prstGeom prst="rect">
+            <a:avLst/>
+          </a:prstGeom>
+          <a:noFill/>
+          <a:ln/>
+        </p:spPr>
+        <p:txBody>
+          <a:bodyPr wrap="square" rtlCol="0" anchor="ctr"/>
+          <a:lstStyle/>
+          <a:p>
+            <a:pPr indent="0" marL="0">
+              <a:buNone/>
+            </a:pPr>
+            <a:r>
+              <a:rPr lang="en-US" sz="1400" dirty="0">
+                <a:solidFill>
+                  <a:srgbClr val="FFFFFF"/>
+                </a:solidFill>
+                <a:latin typeface="微軟正黑體" pitchFamily="34" charset="0"/>
+                <a:ea typeface="微軟正黑體" pitchFamily="34" charset="-122"/>
+                <a:cs typeface="微軟正黑體" pitchFamily="34" charset="-120"/>
+              </a:rPr>
+              <a:t>victor@leyun.com.tw</a:t>
+            </a:r>
+            <a:endParaRPr lang="en-US" sz="1400" dirty="0"/>
+          </a:p>
+        </p:txBody>
+      </p:sp>
+      <p:sp>
+        <p:nvSpPr>
+          <p:cNvPr id="11" name="Text 9"/>
+          <p:cNvSpPr/>
+          <p:nvPr/>
+        </p:nvSpPr>
+        <p:spPr>
+          <a:xfrm>
+            <a:off x="5029200" y="1554480"/>
+            <a:ext cx="6675120" cy="292608"/>
+          </a:xfrm>
+          <a:prstGeom prst="rect">
+            <a:avLst/>
+          </a:prstGeom>
+          <a:noFill/>
+          <a:ln/>
+        </p:spPr>
+        <p:txBody>
+          <a:bodyPr wrap="square" rtlCol="0" anchor="ctr"/>
+          <a:lstStyle/>
+          <a:p>
+            <a:pPr indent="0" marL="0">
+              <a:buNone/>
+            </a:pPr>
+            <a:r>
+              <a:rPr lang="en-US" sz="1100" dirty="0">
+                <a:solidFill>
+                  <a:srgbClr val="888888"/>
+                </a:solidFill>
+                <a:latin typeface="微軟正黑體" pitchFamily="34" charset="0"/>
+                <a:ea typeface="微軟正黑體" pitchFamily="34" charset="-122"/>
+                <a:cs typeface="微軟正黑體" pitchFamily="34" charset="-120"/>
+              </a:rPr>
+              <a:t>Cloudflare AI Gateway 實戰 · 樂雲智能 LEYUN</a:t>
+            </a:r>
+            <a:endParaRPr lang="en-US" sz="1100" dirty="0"/>
+          </a:p>
+        </p:txBody>
+      </p:sp>
+      <p:sp>
+        <p:nvSpPr>
+          <p:cNvPr id="12" name="Shape 10"/>
+          <p:cNvSpPr/>
+          <p:nvPr/>
+        </p:nvSpPr>
+        <p:spPr>
+          <a:xfrm>
+            <a:off x="5029200" y="2011680"/>
+            <a:ext cx="91440" cy="1828800"/>
+          </a:xfrm>
+          <a:prstGeom prst="rect">
+            <a:avLst/>
+          </a:prstGeom>
+          <a:solidFill>
+            <a:srgbClr val="F38020"/>
+          </a:solidFill>
+          <a:ln/>
+        </p:spPr>
+      </p:sp>
+      <p:sp>
+        <p:nvSpPr>
+          <p:cNvPr id="13" name="Text 11"/>
+          <p:cNvSpPr/>
+          <p:nvPr/>
+        </p:nvSpPr>
+        <p:spPr>
+          <a:xfrm>
+            <a:off x="5257800" y="2011680"/>
+            <a:ext cx="6492240" cy="1828800"/>
+          </a:xfrm>
+          <a:prstGeom prst="rect">
+            <a:avLst/>
+          </a:prstGeom>
+          <a:noFill/>
+          <a:ln/>
+        </p:spPr>
+        <p:txBody>
+          <a:bodyPr wrap="square" rtlCol="0" anchor="ctr"/>
+          <a:lstStyle/>
+          <a:p>
+            <a:pPr indent="0" marL="0">
+              <a:lnSpc>
+                <a:spcPct val="115000"/>
+              </a:lnSpc>
+              <a:buNone/>
+            </a:pPr>
+            <a:r>
+              <a:rPr lang="en-US" sz="2800" b="1" dirty="0">
+                <a:solidFill>
+                  <a:srgbClr val="1A1A1A"/>
+                </a:solidFill>
+                <a:latin typeface="微軟正黑體" pitchFamily="34" charset="0"/>
+                <a:ea typeface="微軟正黑體" pitchFamily="34" charset="-122"/>
+                <a:cs typeface="微軟正黑體" pitchFamily="34" charset="-120"/>
+              </a:rPr>
+              <a:t>帶走 Repo</a:t>
+            </a:r>
+            <a:endParaRPr lang="en-US" sz="2800" dirty="0"/>
+          </a:p>
+          <a:p>
+            <a:pPr indent="0" marL="0">
+              <a:lnSpc>
+                <a:spcPct val="115000"/>
+              </a:lnSpc>
+              <a:buNone/>
+            </a:pPr>
+            <a:r>
+              <a:rPr lang="en-US" sz="2800" b="1" dirty="0">
+                <a:solidFill>
+                  <a:srgbClr val="1A1A1A"/>
+                </a:solidFill>
+                <a:latin typeface="微軟正黑體" pitchFamily="34" charset="0"/>
+                <a:ea typeface="微軟正黑體" pitchFamily="34" charset="-122"/>
+                <a:cs typeface="微軟正黑體" pitchFamily="34" charset="-120"/>
+              </a:rPr>
+              <a:t>持續延伸學習</a:t>
+            </a:r>
+            <a:endParaRPr lang="en-US" sz="2800" dirty="0"/>
+          </a:p>
+        </p:txBody>
+      </p:sp>
+      <p:sp>
+        <p:nvSpPr>
+          <p:cNvPr id="14" name="Text 12"/>
+          <p:cNvSpPr/>
+          <p:nvPr/>
+        </p:nvSpPr>
+        <p:spPr>
+          <a:xfrm>
+            <a:off x="5257800" y="3913632"/>
+            <a:ext cx="6492240" cy="457200"/>
+          </a:xfrm>
+          <a:prstGeom prst="rect">
+            <a:avLst/>
+          </a:prstGeom>
+          <a:noFill/>
+          <a:ln/>
+        </p:spPr>
+        <p:txBody>
+          <a:bodyPr wrap="square" rtlCol="0" anchor="ctr"/>
+          <a:lstStyle/>
+          <a:p>
+            <a:pPr indent="0" marL="0">
+              <a:buNone/>
+            </a:pPr>
+            <a:r>
+              <a:rPr lang="en-US" sz="1500" i="1" dirty="0">
+                <a:solidFill>
+                  <a:srgbClr val="444444"/>
+                </a:solidFill>
+                <a:latin typeface="微軟正黑體" pitchFamily="34" charset="0"/>
+                <a:ea typeface="微軟正黑體" pitchFamily="34" charset="-122"/>
+                <a:cs typeface="微軟正黑體" pitchFamily="34" charset="-120"/>
+              </a:rPr>
+              <a:t>README · QUICK-START · COURSE-OUTLINE · cheatsheet 一應俱全</a:t>
+            </a:r>
+            <a:endParaRPr lang="en-US" sz="1500" dirty="0"/>
+          </a:p>
+        </p:txBody>
+      </p:sp>
+      <p:sp>
+        <p:nvSpPr>
+          <p:cNvPr id="15" name="Shape 13"/>
+          <p:cNvSpPr/>
+          <p:nvPr/>
+        </p:nvSpPr>
+        <p:spPr>
+          <a:xfrm>
+            <a:off x="5029200" y="4617720"/>
+            <a:ext cx="64008" cy="384048"/>
+          </a:xfrm>
+          <a:prstGeom prst="rect">
+            <a:avLst/>
+          </a:prstGeom>
+          <a:solidFill>
+            <a:srgbClr val="F38020"/>
+          </a:solidFill>
+          <a:ln/>
+        </p:spPr>
+      </p:sp>
+      <p:sp>
+        <p:nvSpPr>
+          <p:cNvPr id="16" name="Text 14"/>
+          <p:cNvSpPr/>
+          <p:nvPr/>
+        </p:nvSpPr>
+        <p:spPr>
+          <a:xfrm>
+            <a:off x="5212080" y="4617720"/>
+            <a:ext cx="6492240" cy="384048"/>
+          </a:xfrm>
+          <a:prstGeom prst="rect">
+            <a:avLst/>
+          </a:prstGeom>
+          <a:noFill/>
+          <a:ln/>
+        </p:spPr>
+        <p:txBody>
+          <a:bodyPr wrap="square" rtlCol="0" anchor="ctr"/>
+          <a:lstStyle/>
+          <a:p>
+            <a:pPr indent="0" marL="0">
+              <a:buNone/>
+            </a:pPr>
+            <a:r>
+              <a:rPr lang="en-US" sz="1400" b="1" dirty="0">
+                <a:solidFill>
+                  <a:srgbClr val="F38020"/>
+                </a:solidFill>
+                <a:latin typeface="微軟正黑體" pitchFamily="34" charset="0"/>
+                <a:ea typeface="微軟正黑體" pitchFamily="34" charset="-122"/>
+                <a:cs typeface="微軟正黑體" pitchFamily="34" charset="-120"/>
+              </a:rPr>
+              <a:t>NEXT STEP — 課後問題請來信或加入樂雲學員交流社群</a:t>
+            </a:r>
+            <a:endParaRPr lang="en-US" sz="1400" dirty="0"/>
+          </a:p>
+        </p:txBody>
+      </p:sp>
+      <p:sp>
+        <p:nvSpPr>
+          <p:cNvPr id="17" name="Text 15"/>
+          <p:cNvSpPr/>
+          <p:nvPr/>
+        </p:nvSpPr>
+        <p:spPr>
+          <a:xfrm>
+            <a:off x="5212080" y="5074920"/>
+            <a:ext cx="6492240" cy="320040"/>
+          </a:xfrm>
+          <a:prstGeom prst="rect">
+            <a:avLst/>
+          </a:prstGeom>
+          <a:noFill/>
+          <a:ln/>
+        </p:spPr>
+        <p:txBody>
+          <a:bodyPr wrap="square" rtlCol="0" anchor="ctr"/>
+          <a:lstStyle/>
+          <a:p>
+            <a:pPr indent="0" marL="0">
+              <a:buNone/>
+            </a:pPr>
+            <a:r>
+              <a:rPr lang="en-US" sz="1200" dirty="0">
+                <a:solidFill>
+                  <a:srgbClr val="888888"/>
+                </a:solidFill>
+                <a:latin typeface="微軟正黑體" pitchFamily="34" charset="0"/>
+                <a:ea typeface="微軟正黑體" pitchFamily="34" charset="-122"/>
+                <a:cs typeface="微軟正黑體" pitchFamily="34" charset="-120"/>
+              </a:rPr>
+              <a:t>提供 Basic / Advanced / Premium 三層商用方案，PoC 30 天免費試用</a:t>
+            </a:r>
+            <a:endParaRPr lang="en-US" sz="1200" dirty="0"/>
           </a:p>
         </p:txBody>
       </p:sp>
@@ -6938,6 +7430,890 @@
               <a:t>Cloudflare AI Gateway 實戰 · 樂雲課程 · 90 min</a:t>
             </a:r>
             <a:endParaRPr lang="en-US" sz="1000" dirty="0"/>
+          </a:p>
+        </p:txBody>
+      </p:sp>
+      <p:sp>
+        <p:nvSpPr>
+          <p:cNvPr id="8" name="Shape 5"/>
+          <p:cNvSpPr/>
+          <p:nvPr/>
+        </p:nvSpPr>
+        <p:spPr>
+          <a:xfrm>
+            <a:off x="457200" y="1325880"/>
+            <a:ext cx="5554980" cy="2455164"/>
+          </a:xfrm>
+          <a:prstGeom prst="rect">
+            <a:avLst/>
+          </a:prstGeom>
+          <a:solidFill>
+            <a:srgbClr val="FAFBFC"/>
+          </a:solidFill>
+          <a:ln w="12700">
+            <a:solidFill>
+              <a:srgbClr val="E5E7EB"/>
+            </a:solidFill>
+            <a:prstDash val="solid"/>
+          </a:ln>
+        </p:spPr>
+      </p:sp>
+      <p:sp>
+        <p:nvSpPr>
+          <p:cNvPr id="9" name="Shape 6"/>
+          <p:cNvSpPr/>
+          <p:nvPr/>
+        </p:nvSpPr>
+        <p:spPr>
+          <a:xfrm>
+            <a:off x="457200" y="1325880"/>
+            <a:ext cx="64008" cy="2455164"/>
+          </a:xfrm>
+          <a:prstGeom prst="rect">
+            <a:avLst/>
+          </a:prstGeom>
+          <a:solidFill>
+            <a:srgbClr val="F38020"/>
+          </a:solidFill>
+          <a:ln/>
+        </p:spPr>
+      </p:sp>
+      <p:sp>
+        <p:nvSpPr>
+          <p:cNvPr id="10" name="Shape 7"/>
+          <p:cNvSpPr/>
+          <p:nvPr/>
+        </p:nvSpPr>
+        <p:spPr>
+          <a:xfrm>
+            <a:off x="621792" y="2361438"/>
+            <a:ext cx="384048" cy="384048"/>
+          </a:xfrm>
+          <a:prstGeom prst="ellipse">
+            <a:avLst/>
+          </a:prstGeom>
+          <a:solidFill>
+            <a:srgbClr val="F38020"/>
+          </a:solidFill>
+          <a:ln/>
+        </p:spPr>
+      </p:sp>
+      <p:sp>
+        <p:nvSpPr>
+          <p:cNvPr id="11" name="Text 8"/>
+          <p:cNvSpPr/>
+          <p:nvPr/>
+        </p:nvSpPr>
+        <p:spPr>
+          <a:xfrm>
+            <a:off x="621792" y="2361438"/>
+            <a:ext cx="384048" cy="384048"/>
+          </a:xfrm>
+          <a:prstGeom prst="rect">
+            <a:avLst/>
+          </a:prstGeom>
+          <a:noFill/>
+          <a:ln/>
+        </p:spPr>
+        <p:txBody>
+          <a:bodyPr wrap="square" rtlCol="0" anchor="ctr"/>
+          <a:lstStyle/>
+          <a:p>
+            <a:pPr algn="ctr" indent="0" marL="0">
+              <a:buNone/>
+            </a:pPr>
+            <a:r>
+              <a:rPr lang="en-US" sz="1400" b="1" dirty="0">
+                <a:solidFill>
+                  <a:srgbClr val="FFFFFF"/>
+                </a:solidFill>
+                <a:latin typeface="微軟正黑體" pitchFamily="34" charset="0"/>
+                <a:ea typeface="微軟正黑體" pitchFamily="34" charset="-122"/>
+                <a:cs typeface="微軟正黑體" pitchFamily="34" charset="-120"/>
+              </a:rPr>
+              <a:t>01</a:t>
+            </a:r>
+            <a:endParaRPr lang="en-US" sz="1400" dirty="0"/>
+          </a:p>
+        </p:txBody>
+      </p:sp>
+      <p:sp>
+        <p:nvSpPr>
+          <p:cNvPr id="12" name="Text 9"/>
+          <p:cNvSpPr/>
+          <p:nvPr/>
+        </p:nvSpPr>
+        <p:spPr>
+          <a:xfrm>
+            <a:off x="1115568" y="2324862"/>
+            <a:ext cx="475488" cy="457200"/>
+          </a:xfrm>
+          <a:prstGeom prst="rect">
+            <a:avLst/>
+          </a:prstGeom>
+          <a:noFill/>
+          <a:ln/>
+        </p:spPr>
+        <p:txBody>
+          <a:bodyPr wrap="square" rtlCol="0" anchor="ctr"/>
+          <a:lstStyle/>
+          <a:p>
+            <a:pPr indent="0" marL="0">
+              <a:buNone/>
+            </a:pPr>
+            <a:r>
+              <a:rPr lang="en-US" sz="2000" dirty="0">
+                <a:solidFill>
+                  <a:srgbClr val="000000"/>
+                </a:solidFill>
+                <a:latin typeface="微軟正黑體" pitchFamily="34" charset="0"/>
+                <a:ea typeface="微軟正黑體" pitchFamily="34" charset="-122"/>
+                <a:cs typeface="微軟正黑體" pitchFamily="34" charset="-120"/>
+              </a:rPr>
+              <a:t>📘</a:t>
+            </a:r>
+            <a:endParaRPr lang="en-US" sz="2000" dirty="0"/>
+          </a:p>
+        </p:txBody>
+      </p:sp>
+      <p:sp>
+        <p:nvSpPr>
+          <p:cNvPr id="13" name="Text 10"/>
+          <p:cNvSpPr/>
+          <p:nvPr/>
+        </p:nvSpPr>
+        <p:spPr>
+          <a:xfrm>
+            <a:off x="1664208" y="1435608"/>
+            <a:ext cx="4229100" cy="1031169"/>
+          </a:xfrm>
+          <a:prstGeom prst="rect">
+            <a:avLst/>
+          </a:prstGeom>
+          <a:noFill/>
+          <a:ln/>
+        </p:spPr>
+        <p:txBody>
+          <a:bodyPr wrap="square" rtlCol="0" anchor="ctr"/>
+          <a:lstStyle/>
+          <a:p>
+            <a:pPr indent="0" marL="0">
+              <a:buNone/>
+            </a:pPr>
+            <a:r>
+              <a:rPr lang="en-US" sz="1400" b="1" dirty="0">
+                <a:solidFill>
+                  <a:srgbClr val="1A1A1A"/>
+                </a:solidFill>
+                <a:latin typeface="微軟正黑體" pitchFamily="34" charset="0"/>
+                <a:ea typeface="微軟正黑體" pitchFamily="34" charset="-122"/>
+                <a:cs typeface="微軟正黑體" pitchFamily="34" charset="-120"/>
+              </a:rPr>
+              <a:t>Cloudflare AI Gateway 概論</a:t>
+            </a:r>
+            <a:endParaRPr lang="en-US" sz="1400" dirty="0"/>
+          </a:p>
+        </p:txBody>
+      </p:sp>
+      <p:sp>
+        <p:nvSpPr>
+          <p:cNvPr id="14" name="Text 11"/>
+          <p:cNvSpPr/>
+          <p:nvPr/>
+        </p:nvSpPr>
+        <p:spPr>
+          <a:xfrm>
+            <a:off x="1664208" y="2504359"/>
+            <a:ext cx="4229100" cy="1104824"/>
+          </a:xfrm>
+          <a:prstGeom prst="rect">
+            <a:avLst/>
+          </a:prstGeom>
+          <a:noFill/>
+          <a:ln/>
+        </p:spPr>
+        <p:txBody>
+          <a:bodyPr wrap="square" rtlCol="0" anchor="t"/>
+          <a:lstStyle/>
+          <a:p>
+            <a:pPr indent="0" marL="0">
+              <a:buNone/>
+            </a:pPr>
+            <a:r>
+              <a:rPr lang="en-US" sz="1100" dirty="0">
+                <a:solidFill>
+                  <a:srgbClr val="444444"/>
+                </a:solidFill>
+                <a:latin typeface="微軟正黑體" pitchFamily="34" charset="0"/>
+                <a:ea typeface="微軟正黑體" pitchFamily="34" charset="-122"/>
+                <a:cs typeface="微軟正黑體" pitchFamily="34" charset="-120"/>
+              </a:rPr>
+              <a:t>15 min — 痛點 + 三大能力 + BYOK 機制</a:t>
+            </a:r>
+            <a:endParaRPr lang="en-US" sz="1100" dirty="0"/>
+          </a:p>
+        </p:txBody>
+      </p:sp>
+      <p:sp>
+        <p:nvSpPr>
+          <p:cNvPr id="15" name="Shape 12"/>
+          <p:cNvSpPr/>
+          <p:nvPr/>
+        </p:nvSpPr>
+        <p:spPr>
+          <a:xfrm>
+            <a:off x="6176772" y="1325880"/>
+            <a:ext cx="5554980" cy="2455164"/>
+          </a:xfrm>
+          <a:prstGeom prst="rect">
+            <a:avLst/>
+          </a:prstGeom>
+          <a:solidFill>
+            <a:srgbClr val="FAFBFC"/>
+          </a:solidFill>
+          <a:ln w="12700">
+            <a:solidFill>
+              <a:srgbClr val="E5E7EB"/>
+            </a:solidFill>
+            <a:prstDash val="solid"/>
+          </a:ln>
+        </p:spPr>
+      </p:sp>
+      <p:sp>
+        <p:nvSpPr>
+          <p:cNvPr id="16" name="Shape 13"/>
+          <p:cNvSpPr/>
+          <p:nvPr/>
+        </p:nvSpPr>
+        <p:spPr>
+          <a:xfrm>
+            <a:off x="6176772" y="1325880"/>
+            <a:ext cx="64008" cy="2455164"/>
+          </a:xfrm>
+          <a:prstGeom prst="rect">
+            <a:avLst/>
+          </a:prstGeom>
+          <a:solidFill>
+            <a:srgbClr val="F38020"/>
+          </a:solidFill>
+          <a:ln/>
+        </p:spPr>
+      </p:sp>
+      <p:sp>
+        <p:nvSpPr>
+          <p:cNvPr id="17" name="Shape 14"/>
+          <p:cNvSpPr/>
+          <p:nvPr/>
+        </p:nvSpPr>
+        <p:spPr>
+          <a:xfrm>
+            <a:off x="6341364" y="2361438"/>
+            <a:ext cx="384048" cy="384048"/>
+          </a:xfrm>
+          <a:prstGeom prst="ellipse">
+            <a:avLst/>
+          </a:prstGeom>
+          <a:solidFill>
+            <a:srgbClr val="F38020"/>
+          </a:solidFill>
+          <a:ln/>
+        </p:spPr>
+      </p:sp>
+      <p:sp>
+        <p:nvSpPr>
+          <p:cNvPr id="18" name="Text 15"/>
+          <p:cNvSpPr/>
+          <p:nvPr/>
+        </p:nvSpPr>
+        <p:spPr>
+          <a:xfrm>
+            <a:off x="6341364" y="2361438"/>
+            <a:ext cx="384048" cy="384048"/>
+          </a:xfrm>
+          <a:prstGeom prst="rect">
+            <a:avLst/>
+          </a:prstGeom>
+          <a:noFill/>
+          <a:ln/>
+        </p:spPr>
+        <p:txBody>
+          <a:bodyPr wrap="square" rtlCol="0" anchor="ctr"/>
+          <a:lstStyle/>
+          <a:p>
+            <a:pPr algn="ctr" indent="0" marL="0">
+              <a:buNone/>
+            </a:pPr>
+            <a:r>
+              <a:rPr lang="en-US" sz="1400" b="1" dirty="0">
+                <a:solidFill>
+                  <a:srgbClr val="FFFFFF"/>
+                </a:solidFill>
+                <a:latin typeface="微軟正黑體" pitchFamily="34" charset="0"/>
+                <a:ea typeface="微軟正黑體" pitchFamily="34" charset="-122"/>
+                <a:cs typeface="微軟正黑體" pitchFamily="34" charset="-120"/>
+              </a:rPr>
+              <a:t>02</a:t>
+            </a:r>
+            <a:endParaRPr lang="en-US" sz="1400" dirty="0"/>
+          </a:p>
+        </p:txBody>
+      </p:sp>
+      <p:sp>
+        <p:nvSpPr>
+          <p:cNvPr id="19" name="Text 16"/>
+          <p:cNvSpPr/>
+          <p:nvPr/>
+        </p:nvSpPr>
+        <p:spPr>
+          <a:xfrm>
+            <a:off x="6835140" y="2324862"/>
+            <a:ext cx="475488" cy="457200"/>
+          </a:xfrm>
+          <a:prstGeom prst="rect">
+            <a:avLst/>
+          </a:prstGeom>
+          <a:noFill/>
+          <a:ln/>
+        </p:spPr>
+        <p:txBody>
+          <a:bodyPr wrap="square" rtlCol="0" anchor="ctr"/>
+          <a:lstStyle/>
+          <a:p>
+            <a:pPr indent="0" marL="0">
+              <a:buNone/>
+            </a:pPr>
+            <a:r>
+              <a:rPr lang="en-US" sz="2000" dirty="0">
+                <a:solidFill>
+                  <a:srgbClr val="000000"/>
+                </a:solidFill>
+                <a:latin typeface="微軟正黑體" pitchFamily="34" charset="0"/>
+                <a:ea typeface="微軟正黑體" pitchFamily="34" charset="-122"/>
+                <a:cs typeface="微軟正黑體" pitchFamily="34" charset="-120"/>
+              </a:rPr>
+              <a:t>🔍</a:t>
+            </a:r>
+            <a:endParaRPr lang="en-US" sz="2000" dirty="0"/>
+          </a:p>
+        </p:txBody>
+      </p:sp>
+      <p:sp>
+        <p:nvSpPr>
+          <p:cNvPr id="20" name="Text 17"/>
+          <p:cNvSpPr/>
+          <p:nvPr/>
+        </p:nvSpPr>
+        <p:spPr>
+          <a:xfrm>
+            <a:off x="7383780" y="1435608"/>
+            <a:ext cx="4229100" cy="1031169"/>
+          </a:xfrm>
+          <a:prstGeom prst="rect">
+            <a:avLst/>
+          </a:prstGeom>
+          <a:noFill/>
+          <a:ln/>
+        </p:spPr>
+        <p:txBody>
+          <a:bodyPr wrap="square" rtlCol="0" anchor="ctr"/>
+          <a:lstStyle/>
+          <a:p>
+            <a:pPr indent="0" marL="0">
+              <a:buNone/>
+            </a:pPr>
+            <a:r>
+              <a:rPr lang="en-US" sz="1400" b="1" dirty="0">
+                <a:solidFill>
+                  <a:srgbClr val="1A1A1A"/>
+                </a:solidFill>
+                <a:latin typeface="微軟正黑體" pitchFamily="34" charset="0"/>
+                <a:ea typeface="微軟正黑體" pitchFamily="34" charset="-122"/>
+                <a:cs typeface="微軟正黑體" pitchFamily="34" charset="-120"/>
+              </a:rPr>
+              <a:t>實作專案架構導覽</a:t>
+            </a:r>
+            <a:endParaRPr lang="en-US" sz="1400" dirty="0"/>
+          </a:p>
+        </p:txBody>
+      </p:sp>
+      <p:sp>
+        <p:nvSpPr>
+          <p:cNvPr id="21" name="Text 18"/>
+          <p:cNvSpPr/>
+          <p:nvPr/>
+        </p:nvSpPr>
+        <p:spPr>
+          <a:xfrm>
+            <a:off x="7383780" y="2504359"/>
+            <a:ext cx="4229100" cy="1104824"/>
+          </a:xfrm>
+          <a:prstGeom prst="rect">
+            <a:avLst/>
+          </a:prstGeom>
+          <a:noFill/>
+          <a:ln/>
+        </p:spPr>
+        <p:txBody>
+          <a:bodyPr wrap="square" rtlCol="0" anchor="t"/>
+          <a:lstStyle/>
+          <a:p>
+            <a:pPr indent="0" marL="0">
+              <a:buNone/>
+            </a:pPr>
+            <a:r>
+              <a:rPr lang="en-US" sz="1100" dirty="0">
+                <a:solidFill>
+                  <a:srgbClr val="444444"/>
+                </a:solidFill>
+                <a:latin typeface="微軟正黑體" pitchFamily="34" charset="0"/>
+                <a:ea typeface="微軟正黑體" pitchFamily="34" charset="-122"/>
+                <a:cs typeface="微軟正黑體" pitchFamily="34" charset="-120"/>
+              </a:rPr>
+              <a:t>25 min — Code Walk 8 支 src + D1 schema</a:t>
+            </a:r>
+            <a:endParaRPr lang="en-US" sz="1100" dirty="0"/>
+          </a:p>
+        </p:txBody>
+      </p:sp>
+      <p:sp>
+        <p:nvSpPr>
+          <p:cNvPr id="22" name="Shape 19"/>
+          <p:cNvSpPr/>
+          <p:nvPr/>
+        </p:nvSpPr>
+        <p:spPr>
+          <a:xfrm>
+            <a:off x="457200" y="3945636"/>
+            <a:ext cx="5554980" cy="2455164"/>
+          </a:xfrm>
+          <a:prstGeom prst="rect">
+            <a:avLst/>
+          </a:prstGeom>
+          <a:solidFill>
+            <a:srgbClr val="FAFBFC"/>
+          </a:solidFill>
+          <a:ln w="12700">
+            <a:solidFill>
+              <a:srgbClr val="E5E7EB"/>
+            </a:solidFill>
+            <a:prstDash val="solid"/>
+          </a:ln>
+        </p:spPr>
+      </p:sp>
+      <p:sp>
+        <p:nvSpPr>
+          <p:cNvPr id="23" name="Shape 20"/>
+          <p:cNvSpPr/>
+          <p:nvPr/>
+        </p:nvSpPr>
+        <p:spPr>
+          <a:xfrm>
+            <a:off x="457200" y="3945636"/>
+            <a:ext cx="64008" cy="2455164"/>
+          </a:xfrm>
+          <a:prstGeom prst="rect">
+            <a:avLst/>
+          </a:prstGeom>
+          <a:solidFill>
+            <a:srgbClr val="F38020"/>
+          </a:solidFill>
+          <a:ln/>
+        </p:spPr>
+      </p:sp>
+      <p:sp>
+        <p:nvSpPr>
+          <p:cNvPr id="24" name="Shape 21"/>
+          <p:cNvSpPr/>
+          <p:nvPr/>
+        </p:nvSpPr>
+        <p:spPr>
+          <a:xfrm>
+            <a:off x="621792" y="4981194"/>
+            <a:ext cx="384048" cy="384048"/>
+          </a:xfrm>
+          <a:prstGeom prst="ellipse">
+            <a:avLst/>
+          </a:prstGeom>
+          <a:solidFill>
+            <a:srgbClr val="F38020"/>
+          </a:solidFill>
+          <a:ln/>
+        </p:spPr>
+      </p:sp>
+      <p:sp>
+        <p:nvSpPr>
+          <p:cNvPr id="25" name="Text 22"/>
+          <p:cNvSpPr/>
+          <p:nvPr/>
+        </p:nvSpPr>
+        <p:spPr>
+          <a:xfrm>
+            <a:off x="621792" y="4981194"/>
+            <a:ext cx="384048" cy="384048"/>
+          </a:xfrm>
+          <a:prstGeom prst="rect">
+            <a:avLst/>
+          </a:prstGeom>
+          <a:noFill/>
+          <a:ln/>
+        </p:spPr>
+        <p:txBody>
+          <a:bodyPr wrap="square" rtlCol="0" anchor="ctr"/>
+          <a:lstStyle/>
+          <a:p>
+            <a:pPr algn="ctr" indent="0" marL="0">
+              <a:buNone/>
+            </a:pPr>
+            <a:r>
+              <a:rPr lang="en-US" sz="1400" b="1" dirty="0">
+                <a:solidFill>
+                  <a:srgbClr val="FFFFFF"/>
+                </a:solidFill>
+                <a:latin typeface="微軟正黑體" pitchFamily="34" charset="0"/>
+                <a:ea typeface="微軟正黑體" pitchFamily="34" charset="-122"/>
+                <a:cs typeface="微軟正黑體" pitchFamily="34" charset="-120"/>
+              </a:rPr>
+              <a:t>03</a:t>
+            </a:r>
+            <a:endParaRPr lang="en-US" sz="1400" dirty="0"/>
+          </a:p>
+        </p:txBody>
+      </p:sp>
+      <p:sp>
+        <p:nvSpPr>
+          <p:cNvPr id="26" name="Text 23"/>
+          <p:cNvSpPr/>
+          <p:nvPr/>
+        </p:nvSpPr>
+        <p:spPr>
+          <a:xfrm>
+            <a:off x="1115568" y="4944618"/>
+            <a:ext cx="475488" cy="457200"/>
+          </a:xfrm>
+          <a:prstGeom prst="rect">
+            <a:avLst/>
+          </a:prstGeom>
+          <a:noFill/>
+          <a:ln/>
+        </p:spPr>
+        <p:txBody>
+          <a:bodyPr wrap="square" rtlCol="0" anchor="ctr"/>
+          <a:lstStyle/>
+          <a:p>
+            <a:pPr indent="0" marL="0">
+              <a:buNone/>
+            </a:pPr>
+            <a:r>
+              <a:rPr lang="en-US" sz="2000" dirty="0">
+                <a:solidFill>
+                  <a:srgbClr val="000000"/>
+                </a:solidFill>
+                <a:latin typeface="微軟正黑體" pitchFamily="34" charset="0"/>
+                <a:ea typeface="微軟正黑體" pitchFamily="34" charset="-122"/>
+                <a:cs typeface="微軟正黑體" pitchFamily="34" charset="-120"/>
+              </a:rPr>
+              <a:t>🛠</a:t>
+            </a:r>
+            <a:endParaRPr lang="en-US" sz="2000" dirty="0"/>
+          </a:p>
+        </p:txBody>
+      </p:sp>
+      <p:sp>
+        <p:nvSpPr>
+          <p:cNvPr id="27" name="Text 24"/>
+          <p:cNvSpPr/>
+          <p:nvPr/>
+        </p:nvSpPr>
+        <p:spPr>
+          <a:xfrm>
+            <a:off x="1664208" y="4055364"/>
+            <a:ext cx="4229100" cy="1031169"/>
+          </a:xfrm>
+          <a:prstGeom prst="rect">
+            <a:avLst/>
+          </a:prstGeom>
+          <a:noFill/>
+          <a:ln/>
+        </p:spPr>
+        <p:txBody>
+          <a:bodyPr wrap="square" rtlCol="0" anchor="ctr"/>
+          <a:lstStyle/>
+          <a:p>
+            <a:pPr indent="0" marL="0">
+              <a:buNone/>
+            </a:pPr>
+            <a:r>
+              <a:rPr lang="en-US" sz="1400" b="1" dirty="0">
+                <a:solidFill>
+                  <a:srgbClr val="1A1A1A"/>
+                </a:solidFill>
+                <a:latin typeface="微軟正黑體" pitchFamily="34" charset="0"/>
+                <a:ea typeface="微軟正黑體" pitchFamily="34" charset="-122"/>
+                <a:cs typeface="微軟正黑體" pitchFamily="34" charset="-120"/>
+              </a:rPr>
+              <a:t>動手實作</a:t>
+            </a:r>
+            <a:endParaRPr lang="en-US" sz="1400" dirty="0"/>
+          </a:p>
+        </p:txBody>
+      </p:sp>
+      <p:sp>
+        <p:nvSpPr>
+          <p:cNvPr id="28" name="Text 25"/>
+          <p:cNvSpPr/>
+          <p:nvPr/>
+        </p:nvSpPr>
+        <p:spPr>
+          <a:xfrm>
+            <a:off x="1664208" y="5124115"/>
+            <a:ext cx="4229100" cy="1104824"/>
+          </a:xfrm>
+          <a:prstGeom prst="rect">
+            <a:avLst/>
+          </a:prstGeom>
+          <a:noFill/>
+          <a:ln/>
+        </p:spPr>
+        <p:txBody>
+          <a:bodyPr wrap="square" rtlCol="0" anchor="t"/>
+          <a:lstStyle/>
+          <a:p>
+            <a:pPr indent="0" marL="0">
+              <a:buNone/>
+            </a:pPr>
+            <a:r>
+              <a:rPr lang="en-US" sz="1100" dirty="0">
+                <a:solidFill>
+                  <a:srgbClr val="444444"/>
+                </a:solidFill>
+                <a:latin typeface="微軟正黑體" pitchFamily="34" charset="0"/>
+                <a:ea typeface="微軟正黑體" pitchFamily="34" charset="-122"/>
+                <a:cs typeface="微軟正黑體" pitchFamily="34" charset="-120"/>
+              </a:rPr>
+              <a:t>45 min — 4 階段部署你自己的 AI Bot</a:t>
+            </a:r>
+            <a:endParaRPr lang="en-US" sz="1100" dirty="0"/>
+          </a:p>
+        </p:txBody>
+      </p:sp>
+      <p:sp>
+        <p:nvSpPr>
+          <p:cNvPr id="29" name="Shape 26"/>
+          <p:cNvSpPr/>
+          <p:nvPr/>
+        </p:nvSpPr>
+        <p:spPr>
+          <a:xfrm>
+            <a:off x="6176772" y="3945636"/>
+            <a:ext cx="5554980" cy="2455164"/>
+          </a:xfrm>
+          <a:prstGeom prst="rect">
+            <a:avLst/>
+          </a:prstGeom>
+          <a:solidFill>
+            <a:srgbClr val="FAFBFC"/>
+          </a:solidFill>
+          <a:ln w="12700">
+            <a:solidFill>
+              <a:srgbClr val="E5E7EB"/>
+            </a:solidFill>
+            <a:prstDash val="solid"/>
+          </a:ln>
+        </p:spPr>
+      </p:sp>
+      <p:sp>
+        <p:nvSpPr>
+          <p:cNvPr id="30" name="Shape 27"/>
+          <p:cNvSpPr/>
+          <p:nvPr/>
+        </p:nvSpPr>
+        <p:spPr>
+          <a:xfrm>
+            <a:off x="6176772" y="3945636"/>
+            <a:ext cx="64008" cy="2455164"/>
+          </a:xfrm>
+          <a:prstGeom prst="rect">
+            <a:avLst/>
+          </a:prstGeom>
+          <a:solidFill>
+            <a:srgbClr val="F38020"/>
+          </a:solidFill>
+          <a:ln/>
+        </p:spPr>
+      </p:sp>
+      <p:sp>
+        <p:nvSpPr>
+          <p:cNvPr id="31" name="Shape 28"/>
+          <p:cNvSpPr/>
+          <p:nvPr/>
+        </p:nvSpPr>
+        <p:spPr>
+          <a:xfrm>
+            <a:off x="6341364" y="4981194"/>
+            <a:ext cx="384048" cy="384048"/>
+          </a:xfrm>
+          <a:prstGeom prst="ellipse">
+            <a:avLst/>
+          </a:prstGeom>
+          <a:solidFill>
+            <a:srgbClr val="F38020"/>
+          </a:solidFill>
+          <a:ln/>
+        </p:spPr>
+      </p:sp>
+      <p:sp>
+        <p:nvSpPr>
+          <p:cNvPr id="32" name="Text 29"/>
+          <p:cNvSpPr/>
+          <p:nvPr/>
+        </p:nvSpPr>
+        <p:spPr>
+          <a:xfrm>
+            <a:off x="6341364" y="4981194"/>
+            <a:ext cx="384048" cy="384048"/>
+          </a:xfrm>
+          <a:prstGeom prst="rect">
+            <a:avLst/>
+          </a:prstGeom>
+          <a:noFill/>
+          <a:ln/>
+        </p:spPr>
+        <p:txBody>
+          <a:bodyPr wrap="square" rtlCol="0" anchor="ctr"/>
+          <a:lstStyle/>
+          <a:p>
+            <a:pPr algn="ctr" indent="0" marL="0">
+              <a:buNone/>
+            </a:pPr>
+            <a:r>
+              <a:rPr lang="en-US" sz="1400" b="1" dirty="0">
+                <a:solidFill>
+                  <a:srgbClr val="FFFFFF"/>
+                </a:solidFill>
+                <a:latin typeface="微軟正黑體" pitchFamily="34" charset="0"/>
+                <a:ea typeface="微軟正黑體" pitchFamily="34" charset="-122"/>
+                <a:cs typeface="微軟正黑體" pitchFamily="34" charset="-120"/>
+              </a:rPr>
+              <a:t>04</a:t>
+            </a:r>
+            <a:endParaRPr lang="en-US" sz="1400" dirty="0"/>
+          </a:p>
+        </p:txBody>
+      </p:sp>
+      <p:sp>
+        <p:nvSpPr>
+          <p:cNvPr id="33" name="Text 30"/>
+          <p:cNvSpPr/>
+          <p:nvPr/>
+        </p:nvSpPr>
+        <p:spPr>
+          <a:xfrm>
+            <a:off x="6835140" y="4944618"/>
+            <a:ext cx="475488" cy="457200"/>
+          </a:xfrm>
+          <a:prstGeom prst="rect">
+            <a:avLst/>
+          </a:prstGeom>
+          <a:noFill/>
+          <a:ln/>
+        </p:spPr>
+        <p:txBody>
+          <a:bodyPr wrap="square" rtlCol="0" anchor="ctr"/>
+          <a:lstStyle/>
+          <a:p>
+            <a:pPr indent="0" marL="0">
+              <a:buNone/>
+            </a:pPr>
+            <a:r>
+              <a:rPr lang="en-US" sz="2000" dirty="0">
+                <a:solidFill>
+                  <a:srgbClr val="000000"/>
+                </a:solidFill>
+                <a:latin typeface="微軟正黑體" pitchFamily="34" charset="0"/>
+                <a:ea typeface="微軟正黑體" pitchFamily="34" charset="-122"/>
+                <a:cs typeface="微軟正黑體" pitchFamily="34" charset="-120"/>
+              </a:rPr>
+              <a:t>💬</a:t>
+            </a:r>
+            <a:endParaRPr lang="en-US" sz="2000" dirty="0"/>
+          </a:p>
+        </p:txBody>
+      </p:sp>
+      <p:sp>
+        <p:nvSpPr>
+          <p:cNvPr id="34" name="Text 31"/>
+          <p:cNvSpPr/>
+          <p:nvPr/>
+        </p:nvSpPr>
+        <p:spPr>
+          <a:xfrm>
+            <a:off x="7383780" y="4055364"/>
+            <a:ext cx="4229100" cy="1031169"/>
+          </a:xfrm>
+          <a:prstGeom prst="rect">
+            <a:avLst/>
+          </a:prstGeom>
+          <a:noFill/>
+          <a:ln/>
+        </p:spPr>
+        <p:txBody>
+          <a:bodyPr wrap="square" rtlCol="0" anchor="ctr"/>
+          <a:lstStyle/>
+          <a:p>
+            <a:pPr indent="0" marL="0">
+              <a:buNone/>
+            </a:pPr>
+            <a:r>
+              <a:rPr lang="en-US" sz="1400" b="1" dirty="0">
+                <a:solidFill>
+                  <a:srgbClr val="1A1A1A"/>
+                </a:solidFill>
+                <a:latin typeface="微軟正黑體" pitchFamily="34" charset="0"/>
+                <a:ea typeface="微軟正黑體" pitchFamily="34" charset="-122"/>
+                <a:cs typeface="微軟正黑體" pitchFamily="34" charset="-120"/>
+              </a:rPr>
+              <a:t>Q&amp;A + 延伸方向</a:t>
+            </a:r>
+            <a:endParaRPr lang="en-US" sz="1400" dirty="0"/>
+          </a:p>
+        </p:txBody>
+      </p:sp>
+      <p:sp>
+        <p:nvSpPr>
+          <p:cNvPr id="35" name="Text 32"/>
+          <p:cNvSpPr/>
+          <p:nvPr/>
+        </p:nvSpPr>
+        <p:spPr>
+          <a:xfrm>
+            <a:off x="7383780" y="5124115"/>
+            <a:ext cx="4229100" cy="1104824"/>
+          </a:xfrm>
+          <a:prstGeom prst="rect">
+            <a:avLst/>
+          </a:prstGeom>
+          <a:noFill/>
+          <a:ln/>
+        </p:spPr>
+        <p:txBody>
+          <a:bodyPr wrap="square" rtlCol="0" anchor="t"/>
+          <a:lstStyle/>
+          <a:p>
+            <a:pPr indent="0" marL="0">
+              <a:buNone/>
+            </a:pPr>
+            <a:r>
+              <a:rPr lang="en-US" sz="1100" dirty="0">
+                <a:solidFill>
+                  <a:srgbClr val="444444"/>
+                </a:solidFill>
+                <a:latin typeface="微軟正黑體" pitchFamily="34" charset="0"/>
+                <a:ea typeface="微軟正黑體" pitchFamily="34" charset="-122"/>
+                <a:cs typeface="微軟正黑體" pitchFamily="34" charset="-120"/>
+              </a:rPr>
+              <a:t>15 min — 延伸自學地圖 + 樂雲商用方案</a:t>
+            </a:r>
+            <a:endParaRPr lang="en-US" sz="1100" dirty="0"/>
           </a:p>
         </p:txBody>
       </p:sp>

</xml_diff>

<commit_message>
Fix Phase Plan slide + update contact email
- addPhasePlanSlide expected tasks[] not items[], and num not label.
  Without these, the 4-step bullet content was silently dropped,
  leaving only headers + milestone footers visible.
- Update Victor's contact email from victor@leyun.com.tw to
  victor@leyun.cloud in both course slide generators.

Phase Plan slide now has 54 shapes (was 38); all 16 task bullets
(4 phases × 4 tasks) render correctly.
</commit_message>
<xml_diff>
--- a/slides/aigw-course.pptx
+++ b/slides/aigw-course.pptx
@@ -4303,7 +4303,7 @@
             <a:avLst/>
           </a:prstGeom>
           <a:solidFill>
-            <a:srgbClr val="10B981"/>
+            <a:srgbClr val="F38020"/>
           </a:solidFill>
           <a:ln/>
         </p:spPr>
@@ -4341,7 +4341,7 @@
                 <a:ea typeface="Calibri" pitchFamily="34" charset="-122"/>
                 <a:cs typeface="Calibri" pitchFamily="34" charset="-120"/>
               </a:rPr>
-              <a:t>Phase 1</a:t>
+              <a:t>階段 A</a:t>
             </a:r>
             <a:endParaRPr lang="en-US" sz="1400" dirty="0"/>
           </a:p>
@@ -4427,7 +4427,163 @@
       </p:sp>
       <p:sp>
         <p:nvSpPr>
-          <p:cNvPr id="14" name="Shape 11"/>
+          <p:cNvPr id="14" name="Text 11"/>
+          <p:cNvSpPr/>
+          <p:nvPr/>
+        </p:nvSpPr>
+        <p:spPr>
+          <a:xfrm>
+            <a:off x="594360" y="2990088"/>
+            <a:ext cx="2393442" cy="548640"/>
+          </a:xfrm>
+          <a:prstGeom prst="rect">
+            <a:avLst/>
+          </a:prstGeom>
+          <a:noFill/>
+          <a:ln/>
+        </p:spPr>
+        <p:txBody>
+          <a:bodyPr wrap="square" rtlCol="0" anchor="ctr"/>
+          <a:lstStyle/>
+          <a:p>
+            <a:pPr indent="0" marL="0">
+              <a:buNone/>
+            </a:pPr>
+            <a:r>
+              <a:rPr lang="en-US" sz="1100" dirty="0">
+                <a:solidFill>
+                  <a:srgbClr val="444444"/>
+                </a:solidFill>
+                <a:latin typeface="微軟正黑體" pitchFamily="34" charset="0"/>
+                <a:ea typeface="微軟正黑體" pitchFamily="34" charset="-122"/>
+                <a:cs typeface="微軟正黑體" pitchFamily="34" charset="-120"/>
+              </a:rPr>
+              <a:t>▸  git clone &lt;repo&gt;</a:t>
+            </a:r>
+            <a:endParaRPr lang="en-US" sz="1100" dirty="0"/>
+          </a:p>
+        </p:txBody>
+      </p:sp>
+      <p:sp>
+        <p:nvSpPr>
+          <p:cNvPr id="15" name="Text 12"/>
+          <p:cNvSpPr/>
+          <p:nvPr/>
+        </p:nvSpPr>
+        <p:spPr>
+          <a:xfrm>
+            <a:off x="594360" y="3584448"/>
+            <a:ext cx="2393442" cy="548640"/>
+          </a:xfrm>
+          <a:prstGeom prst="rect">
+            <a:avLst/>
+          </a:prstGeom>
+          <a:noFill/>
+          <a:ln/>
+        </p:spPr>
+        <p:txBody>
+          <a:bodyPr wrap="square" rtlCol="0" anchor="ctr"/>
+          <a:lstStyle/>
+          <a:p>
+            <a:pPr indent="0" marL="0">
+              <a:buNone/>
+            </a:pPr>
+            <a:r>
+              <a:rPr lang="en-US" sz="1100" dirty="0">
+                <a:solidFill>
+                  <a:srgbClr val="444444"/>
+                </a:solidFill>
+                <a:latin typeface="微軟正黑體" pitchFamily="34" charset="0"/>
+                <a:ea typeface="微軟正黑體" pitchFamily="34" charset="-122"/>
+                <a:cs typeface="微軟正黑體" pitchFamily="34" charset="-120"/>
+              </a:rPr>
+              <a:t>▸  npm install (worker + frontend)</a:t>
+            </a:r>
+            <a:endParaRPr lang="en-US" sz="1100" dirty="0"/>
+          </a:p>
+        </p:txBody>
+      </p:sp>
+      <p:sp>
+        <p:nvSpPr>
+          <p:cNvPr id="16" name="Text 13"/>
+          <p:cNvSpPr/>
+          <p:nvPr/>
+        </p:nvSpPr>
+        <p:spPr>
+          <a:xfrm>
+            <a:off x="594360" y="4178808"/>
+            <a:ext cx="2393442" cy="548640"/>
+          </a:xfrm>
+          <a:prstGeom prst="rect">
+            <a:avLst/>
+          </a:prstGeom>
+          <a:noFill/>
+          <a:ln/>
+        </p:spPr>
+        <p:txBody>
+          <a:bodyPr wrap="square" rtlCol="0" anchor="ctr"/>
+          <a:lstStyle/>
+          <a:p>
+            <a:pPr indent="0" marL="0">
+              <a:buNone/>
+            </a:pPr>
+            <a:r>
+              <a:rPr lang="en-US" sz="1100" dirty="0">
+                <a:solidFill>
+                  <a:srgbClr val="444444"/>
+                </a:solidFill>
+                <a:latin typeface="微軟正黑體" pitchFamily="34" charset="0"/>
+                <a:ea typeface="微軟正黑體" pitchFamily="34" charset="-122"/>
+                <a:cs typeface="微軟正黑體" pitchFamily="34" charset="-120"/>
+              </a:rPr>
+              <a:t>▸  wrangler login（已預先做完）</a:t>
+            </a:r>
+            <a:endParaRPr lang="en-US" sz="1100" dirty="0"/>
+          </a:p>
+        </p:txBody>
+      </p:sp>
+      <p:sp>
+        <p:nvSpPr>
+          <p:cNvPr id="17" name="Text 14"/>
+          <p:cNvSpPr/>
+          <p:nvPr/>
+        </p:nvSpPr>
+        <p:spPr>
+          <a:xfrm>
+            <a:off x="594360" y="4773168"/>
+            <a:ext cx="2393442" cy="548640"/>
+          </a:xfrm>
+          <a:prstGeom prst="rect">
+            <a:avLst/>
+          </a:prstGeom>
+          <a:noFill/>
+          <a:ln/>
+        </p:spPr>
+        <p:txBody>
+          <a:bodyPr wrap="square" rtlCol="0" anchor="ctr"/>
+          <a:lstStyle/>
+          <a:p>
+            <a:pPr indent="0" marL="0">
+              <a:buNone/>
+            </a:pPr>
+            <a:r>
+              <a:rPr lang="en-US" sz="1100" dirty="0">
+                <a:solidFill>
+                  <a:srgbClr val="444444"/>
+                </a:solidFill>
+                <a:latin typeface="微軟正黑體" pitchFamily="34" charset="0"/>
+                <a:ea typeface="微軟正黑體" pitchFamily="34" charset="-122"/>
+                <a:cs typeface="微軟正黑體" pitchFamily="34" charset="-120"/>
+              </a:rPr>
+              <a:t>▸  wrangler d1 create + kv namespace create</a:t>
+            </a:r>
+            <a:endParaRPr lang="en-US" sz="1100" dirty="0"/>
+          </a:p>
+        </p:txBody>
+      </p:sp>
+      <p:sp>
+        <p:nvSpPr>
+          <p:cNvPr id="18" name="Shape 15"/>
           <p:cNvSpPr/>
           <p:nvPr/>
         </p:nvSpPr>
@@ -4440,14 +4596,14 @@
             <a:avLst/>
           </a:prstGeom>
           <a:solidFill>
-            <a:srgbClr val="10B981"/>
+            <a:srgbClr val="F38020"/>
           </a:solidFill>
           <a:ln/>
         </p:spPr>
       </p:sp>
       <p:sp>
         <p:nvSpPr>
-          <p:cNvPr id="15" name="Text 12"/>
+          <p:cNvPr id="19" name="Text 16"/>
           <p:cNvSpPr/>
           <p:nvPr/>
         </p:nvSpPr>
@@ -4486,7 +4642,7 @@
       </p:sp>
       <p:sp>
         <p:nvSpPr>
-          <p:cNvPr id="16" name="Shape 13"/>
+          <p:cNvPr id="20" name="Shape 17"/>
           <p:cNvSpPr/>
           <p:nvPr/>
         </p:nvSpPr>
@@ -4506,7 +4662,7 @@
       </p:sp>
       <p:sp>
         <p:nvSpPr>
-          <p:cNvPr id="17" name="Shape 14"/>
+          <p:cNvPr id="21" name="Shape 18"/>
           <p:cNvSpPr/>
           <p:nvPr/>
         </p:nvSpPr>
@@ -4531,7 +4687,7 @@
       </p:sp>
       <p:sp>
         <p:nvSpPr>
-          <p:cNvPr id="18" name="Shape 15"/>
+          <p:cNvPr id="22" name="Shape 19"/>
           <p:cNvSpPr/>
           <p:nvPr/>
         </p:nvSpPr>
@@ -4541,6 +4697,358 @@
             <a:ext cx="2667762" cy="530352"/>
           </a:xfrm>
           <a:prstGeom prst="rect">
+            <a:avLst/>
+          </a:prstGeom>
+          <a:solidFill>
+            <a:srgbClr val="10B981"/>
+          </a:solidFill>
+          <a:ln/>
+        </p:spPr>
+      </p:sp>
+      <p:sp>
+        <p:nvSpPr>
+          <p:cNvPr id="23" name="Text 20"/>
+          <p:cNvSpPr/>
+          <p:nvPr/>
+        </p:nvSpPr>
+        <p:spPr>
+          <a:xfrm>
+            <a:off x="3326130" y="1572768"/>
+            <a:ext cx="1200493" cy="530352"/>
+          </a:xfrm>
+          <a:prstGeom prst="rect">
+            <a:avLst/>
+          </a:prstGeom>
+          <a:noFill/>
+          <a:ln/>
+        </p:spPr>
+        <p:txBody>
+          <a:bodyPr wrap="square" rtlCol="0" anchor="ctr"/>
+          <a:lstStyle/>
+          <a:p>
+            <a:pPr algn="ctr" indent="0" marL="0">
+              <a:buNone/>
+            </a:pPr>
+            <a:r>
+              <a:rPr lang="en-US" sz="1400" b="1" dirty="0">
+                <a:solidFill>
+                  <a:srgbClr val="FFFFFF"/>
+                </a:solidFill>
+                <a:latin typeface="Calibri" pitchFamily="34" charset="0"/>
+                <a:ea typeface="Calibri" pitchFamily="34" charset="-122"/>
+                <a:cs typeface="Calibri" pitchFamily="34" charset="-120"/>
+              </a:rPr>
+              <a:t>階段 B</a:t>
+            </a:r>
+            <a:endParaRPr lang="en-US" sz="1400" dirty="0"/>
+          </a:p>
+        </p:txBody>
+      </p:sp>
+      <p:sp>
+        <p:nvSpPr>
+          <p:cNvPr id="24" name="Text 21"/>
+          <p:cNvSpPr/>
+          <p:nvPr/>
+        </p:nvSpPr>
+        <p:spPr>
+          <a:xfrm>
+            <a:off x="4526623" y="1572768"/>
+            <a:ext cx="1467269" cy="530352"/>
+          </a:xfrm>
+          <a:prstGeom prst="rect">
+            <a:avLst/>
+          </a:prstGeom>
+          <a:noFill/>
+          <a:ln/>
+        </p:spPr>
+        <p:txBody>
+          <a:bodyPr wrap="square" rtlCol="0" anchor="ctr"/>
+          <a:lstStyle/>
+          <a:p>
+            <a:pPr indent="0" marL="0">
+              <a:buNone/>
+            </a:pPr>
+            <a:r>
+              <a:rPr lang="en-US" sz="1000" dirty="0">
+                <a:solidFill>
+                  <a:srgbClr val="FFFFFF"/>
+                </a:solidFill>
+                <a:latin typeface="微軟正黑體" pitchFamily="34" charset="0"/>
+                <a:ea typeface="微軟正黑體" pitchFamily="34" charset="-122"/>
+                <a:cs typeface="微軟正黑體" pitchFamily="34" charset="-120"/>
+              </a:rPr>
+              <a:t>15 min</a:t>
+            </a:r>
+            <a:endParaRPr lang="en-US" sz="1000" dirty="0"/>
+          </a:p>
+        </p:txBody>
+      </p:sp>
+      <p:sp>
+        <p:nvSpPr>
+          <p:cNvPr id="25" name="Text 22"/>
+          <p:cNvSpPr/>
+          <p:nvPr/>
+        </p:nvSpPr>
+        <p:spPr>
+          <a:xfrm>
+            <a:off x="3463290" y="2194560"/>
+            <a:ext cx="2393442" cy="384048"/>
+          </a:xfrm>
+          <a:prstGeom prst="rect">
+            <a:avLst/>
+          </a:prstGeom>
+          <a:noFill/>
+          <a:ln/>
+        </p:spPr>
+        <p:txBody>
+          <a:bodyPr wrap="square" rtlCol="0" anchor="ctr"/>
+          <a:lstStyle/>
+          <a:p>
+            <a:pPr indent="0" marL="0">
+              <a:buNone/>
+            </a:pPr>
+            <a:r>
+              <a:rPr lang="en-US" sz="1500" b="1" dirty="0">
+                <a:solidFill>
+                  <a:srgbClr val="1A1A1A"/>
+                </a:solidFill>
+                <a:latin typeface="微軟正黑體" pitchFamily="34" charset="0"/>
+                <a:ea typeface="微軟正黑體" pitchFamily="34" charset="-122"/>
+                <a:cs typeface="微軟正黑體" pitchFamily="34" charset="-120"/>
+              </a:rPr>
+              <a:t>設定金鑰</a:t>
+            </a:r>
+            <a:endParaRPr lang="en-US" sz="1500" dirty="0"/>
+          </a:p>
+        </p:txBody>
+      </p:sp>
+      <p:sp>
+        <p:nvSpPr>
+          <p:cNvPr id="26" name="Text 23"/>
+          <p:cNvSpPr/>
+          <p:nvPr/>
+        </p:nvSpPr>
+        <p:spPr>
+          <a:xfrm>
+            <a:off x="3463290" y="2990088"/>
+            <a:ext cx="2393442" cy="548640"/>
+          </a:xfrm>
+          <a:prstGeom prst="rect">
+            <a:avLst/>
+          </a:prstGeom>
+          <a:noFill/>
+          <a:ln/>
+        </p:spPr>
+        <p:txBody>
+          <a:bodyPr wrap="square" rtlCol="0" anchor="ctr"/>
+          <a:lstStyle/>
+          <a:p>
+            <a:pPr indent="0" marL="0">
+              <a:buNone/>
+            </a:pPr>
+            <a:r>
+              <a:rPr lang="en-US" sz="1100" dirty="0">
+                <a:solidFill>
+                  <a:srgbClr val="444444"/>
+                </a:solidFill>
+                <a:latin typeface="微軟正黑體" pitchFamily="34" charset="0"/>
+                <a:ea typeface="微軟正黑體" pitchFamily="34" charset="-122"/>
+                <a:cs typeface="微軟正黑體" pitchFamily="34" charset="-120"/>
+              </a:rPr>
+              <a:t>▸  Dashboard 建 AI Gateway → Gateway Token</a:t>
+            </a:r>
+            <a:endParaRPr lang="en-US" sz="1100" dirty="0"/>
+          </a:p>
+        </p:txBody>
+      </p:sp>
+      <p:sp>
+        <p:nvSpPr>
+          <p:cNvPr id="27" name="Text 24"/>
+          <p:cNvSpPr/>
+          <p:nvPr/>
+        </p:nvSpPr>
+        <p:spPr>
+          <a:xfrm>
+            <a:off x="3463290" y="3584448"/>
+            <a:ext cx="2393442" cy="548640"/>
+          </a:xfrm>
+          <a:prstGeom prst="rect">
+            <a:avLst/>
+          </a:prstGeom>
+          <a:noFill/>
+          <a:ln/>
+        </p:spPr>
+        <p:txBody>
+          <a:bodyPr wrap="square" rtlCol="0" anchor="ctr"/>
+          <a:lstStyle/>
+          <a:p>
+            <a:pPr indent="0" marL="0">
+              <a:buNone/>
+            </a:pPr>
+            <a:r>
+              <a:rPr lang="en-US" sz="1100" dirty="0">
+                <a:solidFill>
+                  <a:srgbClr val="444444"/>
+                </a:solidFill>
+                <a:latin typeface="微軟正黑體" pitchFamily="34" charset="0"/>
+                <a:ea typeface="微軟正黑體" pitchFamily="34" charset="-122"/>
+                <a:cs typeface="微軟正黑體" pitchFamily="34" charset="-120"/>
+              </a:rPr>
+              <a:t>▸  設定 BYOK alias (claude_demo)</a:t>
+            </a:r>
+            <a:endParaRPr lang="en-US" sz="1100" dirty="0"/>
+          </a:p>
+        </p:txBody>
+      </p:sp>
+      <p:sp>
+        <p:nvSpPr>
+          <p:cNvPr id="28" name="Text 25"/>
+          <p:cNvSpPr/>
+          <p:nvPr/>
+        </p:nvSpPr>
+        <p:spPr>
+          <a:xfrm>
+            <a:off x="3463290" y="4178808"/>
+            <a:ext cx="2393442" cy="548640"/>
+          </a:xfrm>
+          <a:prstGeom prst="rect">
+            <a:avLst/>
+          </a:prstGeom>
+          <a:noFill/>
+          <a:ln/>
+        </p:spPr>
+        <p:txBody>
+          <a:bodyPr wrap="square" rtlCol="0" anchor="ctr"/>
+          <a:lstStyle/>
+          <a:p>
+            <a:pPr indent="0" marL="0">
+              <a:buNone/>
+            </a:pPr>
+            <a:r>
+              <a:rPr lang="en-US" sz="1100" dirty="0">
+                <a:solidFill>
+                  <a:srgbClr val="444444"/>
+                </a:solidFill>
+                <a:latin typeface="微軟正黑體" pitchFamily="34" charset="0"/>
+                <a:ea typeface="微軟正黑體" pitchFamily="34" charset="-122"/>
+                <a:cs typeface="微軟正黑體" pitchFamily="34" charset="-120"/>
+              </a:rPr>
+              <a:t>▸  cp wrangler.toml.example → 填 5 個 ID</a:t>
+            </a:r>
+            <a:endParaRPr lang="en-US" sz="1100" dirty="0"/>
+          </a:p>
+        </p:txBody>
+      </p:sp>
+      <p:sp>
+        <p:nvSpPr>
+          <p:cNvPr id="29" name="Text 26"/>
+          <p:cNvSpPr/>
+          <p:nvPr/>
+        </p:nvSpPr>
+        <p:spPr>
+          <a:xfrm>
+            <a:off x="3463290" y="4773168"/>
+            <a:ext cx="2393442" cy="548640"/>
+          </a:xfrm>
+          <a:prstGeom prst="rect">
+            <a:avLst/>
+          </a:prstGeom>
+          <a:noFill/>
+          <a:ln/>
+        </p:spPr>
+        <p:txBody>
+          <a:bodyPr wrap="square" rtlCol="0" anchor="ctr"/>
+          <a:lstStyle/>
+          <a:p>
+            <a:pPr indent="0" marL="0">
+              <a:buNone/>
+            </a:pPr>
+            <a:r>
+              <a:rPr lang="en-US" sz="1100" dirty="0">
+                <a:solidFill>
+                  <a:srgbClr val="444444"/>
+                </a:solidFill>
+                <a:latin typeface="微軟正黑體" pitchFamily="34" charset="0"/>
+                <a:ea typeface="微軟正黑體" pitchFamily="34" charset="-122"/>
+                <a:cs typeface="微軟正黑體" pitchFamily="34" charset="-120"/>
+              </a:rPr>
+              <a:t>▸  wrangler secret put × 2</a:t>
+            </a:r>
+            <a:endParaRPr lang="en-US" sz="1100" dirty="0"/>
+          </a:p>
+        </p:txBody>
+      </p:sp>
+      <p:sp>
+        <p:nvSpPr>
+          <p:cNvPr id="30" name="Shape 27"/>
+          <p:cNvSpPr/>
+          <p:nvPr/>
+        </p:nvSpPr>
+        <p:spPr>
+          <a:xfrm>
+            <a:off x="3463290" y="6080760"/>
+            <a:ext cx="2393442" cy="384048"/>
+          </a:xfrm>
+          <a:prstGeom prst="rect">
+            <a:avLst/>
+          </a:prstGeom>
+          <a:solidFill>
+            <a:srgbClr val="10B981"/>
+          </a:solidFill>
+          <a:ln/>
+        </p:spPr>
+      </p:sp>
+      <p:sp>
+        <p:nvSpPr>
+          <p:cNvPr id="31" name="Text 28"/>
+          <p:cNvSpPr/>
+          <p:nvPr/>
+        </p:nvSpPr>
+        <p:spPr>
+          <a:xfrm>
+            <a:off x="3463290" y="6080760"/>
+            <a:ext cx="2393442" cy="384048"/>
+          </a:xfrm>
+          <a:prstGeom prst="rect">
+            <a:avLst/>
+          </a:prstGeom>
+          <a:noFill/>
+          <a:ln/>
+        </p:spPr>
+        <p:txBody>
+          <a:bodyPr wrap="square" rtlCol="0" anchor="ctr"/>
+          <a:lstStyle/>
+          <a:p>
+            <a:pPr algn="ctr" indent="0" marL="0">
+              <a:buNone/>
+            </a:pPr>
+            <a:r>
+              <a:rPr lang="en-US" sz="1200" b="1" dirty="0">
+                <a:solidFill>
+                  <a:srgbClr val="FFFFFF"/>
+                </a:solidFill>
+                <a:latin typeface="微軟正黑體" pitchFamily="34" charset="0"/>
+                <a:ea typeface="微軟正黑體" pitchFamily="34" charset="-122"/>
+                <a:cs typeface="微軟正黑體" pitchFamily="34" charset="-120"/>
+              </a:rPr>
+              <a:t>wrangler.toml 完整可用</a:t>
+            </a:r>
+            <a:endParaRPr lang="en-US" sz="1200" dirty="0"/>
+          </a:p>
+        </p:txBody>
+      </p:sp>
+      <p:sp>
+        <p:nvSpPr>
+          <p:cNvPr id="32" name="Shape 29"/>
+          <p:cNvSpPr/>
+          <p:nvPr/>
+        </p:nvSpPr>
+        <p:spPr>
+          <a:xfrm rot="5400000">
+            <a:off x="5993892" y="3918204"/>
+            <a:ext cx="201168" cy="292608"/>
+          </a:xfrm>
+          <a:prstGeom prst="triangle">
             <a:avLst/>
           </a:prstGeom>
           <a:solidFill>
@@ -4551,203 +5059,7 @@
       </p:sp>
       <p:sp>
         <p:nvSpPr>
-          <p:cNvPr id="19" name="Text 16"/>
-          <p:cNvSpPr/>
-          <p:nvPr/>
-        </p:nvSpPr>
-        <p:spPr>
-          <a:xfrm>
-            <a:off x="3326130" y="1572768"/>
-            <a:ext cx="1200493" cy="530352"/>
-          </a:xfrm>
-          <a:prstGeom prst="rect">
-            <a:avLst/>
-          </a:prstGeom>
-          <a:noFill/>
-          <a:ln/>
-        </p:spPr>
-        <p:txBody>
-          <a:bodyPr wrap="square" rtlCol="0" anchor="ctr"/>
-          <a:lstStyle/>
-          <a:p>
-            <a:pPr algn="ctr" indent="0" marL="0">
-              <a:buNone/>
-            </a:pPr>
-            <a:r>
-              <a:rPr lang="en-US" sz="1400" b="1" dirty="0">
-                <a:solidFill>
-                  <a:srgbClr val="FFFFFF"/>
-                </a:solidFill>
-                <a:latin typeface="Calibri" pitchFamily="34" charset="0"/>
-                <a:ea typeface="Calibri" pitchFamily="34" charset="-122"/>
-                <a:cs typeface="Calibri" pitchFamily="34" charset="-120"/>
-              </a:rPr>
-              <a:t>Phase 2</a:t>
-            </a:r>
-            <a:endParaRPr lang="en-US" sz="1400" dirty="0"/>
-          </a:p>
-        </p:txBody>
-      </p:sp>
-      <p:sp>
-        <p:nvSpPr>
-          <p:cNvPr id="20" name="Text 17"/>
-          <p:cNvSpPr/>
-          <p:nvPr/>
-        </p:nvSpPr>
-        <p:spPr>
-          <a:xfrm>
-            <a:off x="4526623" y="1572768"/>
-            <a:ext cx="1467269" cy="530352"/>
-          </a:xfrm>
-          <a:prstGeom prst="rect">
-            <a:avLst/>
-          </a:prstGeom>
-          <a:noFill/>
-          <a:ln/>
-        </p:spPr>
-        <p:txBody>
-          <a:bodyPr wrap="square" rtlCol="0" anchor="ctr"/>
-          <a:lstStyle/>
-          <a:p>
-            <a:pPr indent="0" marL="0">
-              <a:buNone/>
-            </a:pPr>
-            <a:r>
-              <a:rPr lang="en-US" sz="1000" dirty="0">
-                <a:solidFill>
-                  <a:srgbClr val="FFFFFF"/>
-                </a:solidFill>
-                <a:latin typeface="微軟正黑體" pitchFamily="34" charset="0"/>
-                <a:ea typeface="微軟正黑體" pitchFamily="34" charset="-122"/>
-                <a:cs typeface="微軟正黑體" pitchFamily="34" charset="-120"/>
-              </a:rPr>
-              <a:t>15 min</a:t>
-            </a:r>
-            <a:endParaRPr lang="en-US" sz="1000" dirty="0"/>
-          </a:p>
-        </p:txBody>
-      </p:sp>
-      <p:sp>
-        <p:nvSpPr>
-          <p:cNvPr id="21" name="Text 18"/>
-          <p:cNvSpPr/>
-          <p:nvPr/>
-        </p:nvSpPr>
-        <p:spPr>
-          <a:xfrm>
-            <a:off x="3463290" y="2194560"/>
-            <a:ext cx="2393442" cy="384048"/>
-          </a:xfrm>
-          <a:prstGeom prst="rect">
-            <a:avLst/>
-          </a:prstGeom>
-          <a:noFill/>
-          <a:ln/>
-        </p:spPr>
-        <p:txBody>
-          <a:bodyPr wrap="square" rtlCol="0" anchor="ctr"/>
-          <a:lstStyle/>
-          <a:p>
-            <a:pPr indent="0" marL="0">
-              <a:buNone/>
-            </a:pPr>
-            <a:r>
-              <a:rPr lang="en-US" sz="1500" b="1" dirty="0">
-                <a:solidFill>
-                  <a:srgbClr val="1A1A1A"/>
-                </a:solidFill>
-                <a:latin typeface="微軟正黑體" pitchFamily="34" charset="0"/>
-                <a:ea typeface="微軟正黑體" pitchFamily="34" charset="-122"/>
-                <a:cs typeface="微軟正黑體" pitchFamily="34" charset="-120"/>
-              </a:rPr>
-              <a:t>設定金鑰</a:t>
-            </a:r>
-            <a:endParaRPr lang="en-US" sz="1500" dirty="0"/>
-          </a:p>
-        </p:txBody>
-      </p:sp>
-      <p:sp>
-        <p:nvSpPr>
-          <p:cNvPr id="22" name="Shape 19"/>
-          <p:cNvSpPr/>
-          <p:nvPr/>
-        </p:nvSpPr>
-        <p:spPr>
-          <a:xfrm>
-            <a:off x="3463290" y="6080760"/>
-            <a:ext cx="2393442" cy="384048"/>
-          </a:xfrm>
-          <a:prstGeom prst="rect">
-            <a:avLst/>
-          </a:prstGeom>
-          <a:solidFill>
-            <a:srgbClr val="F38020"/>
-          </a:solidFill>
-          <a:ln/>
-        </p:spPr>
-      </p:sp>
-      <p:sp>
-        <p:nvSpPr>
-          <p:cNvPr id="23" name="Text 20"/>
-          <p:cNvSpPr/>
-          <p:nvPr/>
-        </p:nvSpPr>
-        <p:spPr>
-          <a:xfrm>
-            <a:off x="3463290" y="6080760"/>
-            <a:ext cx="2393442" cy="384048"/>
-          </a:xfrm>
-          <a:prstGeom prst="rect">
-            <a:avLst/>
-          </a:prstGeom>
-          <a:noFill/>
-          <a:ln/>
-        </p:spPr>
-        <p:txBody>
-          <a:bodyPr wrap="square" rtlCol="0" anchor="ctr"/>
-          <a:lstStyle/>
-          <a:p>
-            <a:pPr algn="ctr" indent="0" marL="0">
-              <a:buNone/>
-            </a:pPr>
-            <a:r>
-              <a:rPr lang="en-US" sz="1200" b="1" dirty="0">
-                <a:solidFill>
-                  <a:srgbClr val="FFFFFF"/>
-                </a:solidFill>
-                <a:latin typeface="微軟正黑體" pitchFamily="34" charset="0"/>
-                <a:ea typeface="微軟正黑體" pitchFamily="34" charset="-122"/>
-                <a:cs typeface="微軟正黑體" pitchFamily="34" charset="-120"/>
-              </a:rPr>
-              <a:t>wrangler.toml 完整可用</a:t>
-            </a:r>
-            <a:endParaRPr lang="en-US" sz="1200" dirty="0"/>
-          </a:p>
-        </p:txBody>
-      </p:sp>
-      <p:sp>
-        <p:nvSpPr>
-          <p:cNvPr id="24" name="Shape 21"/>
-          <p:cNvSpPr/>
-          <p:nvPr/>
-        </p:nvSpPr>
-        <p:spPr>
-          <a:xfrm rot="5400000">
-            <a:off x="5993892" y="3918204"/>
-            <a:ext cx="201168" cy="292608"/>
-          </a:xfrm>
-          <a:prstGeom prst="triangle">
-            <a:avLst/>
-          </a:prstGeom>
-          <a:solidFill>
-            <a:srgbClr val="F38020"/>
-          </a:solidFill>
-          <a:ln/>
-        </p:spPr>
-      </p:sp>
-      <p:sp>
-        <p:nvSpPr>
-          <p:cNvPr id="25" name="Shape 22"/>
+          <p:cNvPr id="33" name="Shape 30"/>
           <p:cNvSpPr/>
           <p:nvPr/>
         </p:nvSpPr>
@@ -4772,7 +5084,7 @@
       </p:sp>
       <p:sp>
         <p:nvSpPr>
-          <p:cNvPr id="26" name="Shape 23"/>
+          <p:cNvPr id="34" name="Shape 31"/>
           <p:cNvSpPr/>
           <p:nvPr/>
         </p:nvSpPr>
@@ -4785,14 +5097,14 @@
             <a:avLst/>
           </a:prstGeom>
           <a:solidFill>
-            <a:srgbClr val="1E2761"/>
+            <a:srgbClr val="8B5CF6"/>
           </a:solidFill>
           <a:ln/>
         </p:spPr>
       </p:sp>
       <p:sp>
         <p:nvSpPr>
-          <p:cNvPr id="27" name="Text 24"/>
+          <p:cNvPr id="35" name="Text 32"/>
           <p:cNvSpPr/>
           <p:nvPr/>
         </p:nvSpPr>
@@ -4823,7 +5135,7 @@
                 <a:ea typeface="Calibri" pitchFamily="34" charset="-122"/>
                 <a:cs typeface="Calibri" pitchFamily="34" charset="-120"/>
               </a:rPr>
-              <a:t>Phase 3</a:t>
+              <a:t>階段 C</a:t>
             </a:r>
             <a:endParaRPr lang="en-US" sz="1400" dirty="0"/>
           </a:p>
@@ -4831,7 +5143,7 @@
       </p:sp>
       <p:sp>
         <p:nvSpPr>
-          <p:cNvPr id="28" name="Text 25"/>
+          <p:cNvPr id="36" name="Text 33"/>
           <p:cNvSpPr/>
           <p:nvPr/>
         </p:nvSpPr>
@@ -4870,7 +5182,7 @@
       </p:sp>
       <p:sp>
         <p:nvSpPr>
-          <p:cNvPr id="29" name="Text 26"/>
+          <p:cNvPr id="37" name="Text 34"/>
           <p:cNvSpPr/>
           <p:nvPr/>
         </p:nvSpPr>
@@ -4909,7 +5221,163 @@
       </p:sp>
       <p:sp>
         <p:nvSpPr>
-          <p:cNvPr id="30" name="Shape 27"/>
+          <p:cNvPr id="38" name="Text 35"/>
+          <p:cNvSpPr/>
+          <p:nvPr/>
+        </p:nvSpPr>
+        <p:spPr>
+          <a:xfrm>
+            <a:off x="6332220" y="2990088"/>
+            <a:ext cx="2393442" cy="548640"/>
+          </a:xfrm>
+          <a:prstGeom prst="rect">
+            <a:avLst/>
+          </a:prstGeom>
+          <a:noFill/>
+          <a:ln/>
+        </p:spPr>
+        <p:txBody>
+          <a:bodyPr wrap="square" rtlCol="0" anchor="ctr"/>
+          <a:lstStyle/>
+          <a:p>
+            <a:pPr indent="0" marL="0">
+              <a:buNone/>
+            </a:pPr>
+            <a:r>
+              <a:rPr lang="en-US" sz="1100" dirty="0">
+                <a:solidFill>
+                  <a:srgbClr val="444444"/>
+                </a:solidFill>
+                <a:latin typeface="微軟正黑體" pitchFamily="34" charset="0"/>
+                <a:ea typeface="微軟正黑體" pitchFamily="34" charset="-122"/>
+                <a:cs typeface="微軟正黑體" pitchFamily="34" charset="-120"/>
+              </a:rPr>
+              <a:t>▸  npm run db:init</a:t>
+            </a:r>
+            <a:endParaRPr lang="en-US" sz="1100" dirty="0"/>
+          </a:p>
+        </p:txBody>
+      </p:sp>
+      <p:sp>
+        <p:nvSpPr>
+          <p:cNvPr id="39" name="Text 36"/>
+          <p:cNvSpPr/>
+          <p:nvPr/>
+        </p:nvSpPr>
+        <p:spPr>
+          <a:xfrm>
+            <a:off x="6332220" y="3584448"/>
+            <a:ext cx="2393442" cy="548640"/>
+          </a:xfrm>
+          <a:prstGeom prst="rect">
+            <a:avLst/>
+          </a:prstGeom>
+          <a:noFill/>
+          <a:ln/>
+        </p:spPr>
+        <p:txBody>
+          <a:bodyPr wrap="square" rtlCol="0" anchor="ctr"/>
+          <a:lstStyle/>
+          <a:p>
+            <a:pPr indent="0" marL="0">
+              <a:buNone/>
+            </a:pPr>
+            <a:r>
+              <a:rPr lang="en-US" sz="1100" dirty="0">
+                <a:solidFill>
+                  <a:srgbClr val="444444"/>
+                </a:solidFill>
+                <a:latin typeface="微軟正黑體" pitchFamily="34" charset="0"/>
+                <a:ea typeface="微軟正黑體" pitchFamily="34" charset="-122"/>
+                <a:cs typeface="微軟正黑體" pitchFamily="34" charset="-120"/>
+              </a:rPr>
+              <a:t>▸  npm run deploy (Worker)</a:t>
+            </a:r>
+            <a:endParaRPr lang="en-US" sz="1100" dirty="0"/>
+          </a:p>
+        </p:txBody>
+      </p:sp>
+      <p:sp>
+        <p:nvSpPr>
+          <p:cNvPr id="40" name="Text 37"/>
+          <p:cNvSpPr/>
+          <p:nvPr/>
+        </p:nvSpPr>
+        <p:spPr>
+          <a:xfrm>
+            <a:off x="6332220" y="4178808"/>
+            <a:ext cx="2393442" cy="548640"/>
+          </a:xfrm>
+          <a:prstGeom prst="rect">
+            <a:avLst/>
+          </a:prstGeom>
+          <a:noFill/>
+          <a:ln/>
+        </p:spPr>
+        <p:txBody>
+          <a:bodyPr wrap="square" rtlCol="0" anchor="ctr"/>
+          <a:lstStyle/>
+          <a:p>
+            <a:pPr indent="0" marL="0">
+              <a:buNone/>
+            </a:pPr>
+            <a:r>
+              <a:rPr lang="en-US" sz="1100" dirty="0">
+                <a:solidFill>
+                  <a:srgbClr val="444444"/>
+                </a:solidFill>
+                <a:latin typeface="微軟正黑體" pitchFamily="34" charset="0"/>
+                <a:ea typeface="微軟正黑體" pitchFamily="34" charset="-122"/>
+                <a:cs typeface="微軟正黑體" pitchFamily="34" charset="-120"/>
+              </a:rPr>
+              <a:t>▸  前端 npm run build &amp;&amp; deploy</a:t>
+            </a:r>
+            <a:endParaRPr lang="en-US" sz="1100" dirty="0"/>
+          </a:p>
+        </p:txBody>
+      </p:sp>
+      <p:sp>
+        <p:nvSpPr>
+          <p:cNvPr id="41" name="Text 38"/>
+          <p:cNvSpPr/>
+          <p:nvPr/>
+        </p:nvSpPr>
+        <p:spPr>
+          <a:xfrm>
+            <a:off x="6332220" y="4773168"/>
+            <a:ext cx="2393442" cy="548640"/>
+          </a:xfrm>
+          <a:prstGeom prst="rect">
+            <a:avLst/>
+          </a:prstGeom>
+          <a:noFill/>
+          <a:ln/>
+        </p:spPr>
+        <p:txBody>
+          <a:bodyPr wrap="square" rtlCol="0" anchor="ctr"/>
+          <a:lstStyle/>
+          <a:p>
+            <a:pPr indent="0" marL="0">
+              <a:buNone/>
+            </a:pPr>
+            <a:r>
+              <a:rPr lang="en-US" sz="1100" dirty="0">
+                <a:solidFill>
+                  <a:srgbClr val="444444"/>
+                </a:solidFill>
+                <a:latin typeface="微軟正黑體" pitchFamily="34" charset="0"/>
+                <a:ea typeface="微軟正黑體" pitchFamily="34" charset="-122"/>
+                <a:cs typeface="微軟正黑體" pitchFamily="34" charset="-120"/>
+              </a:rPr>
+              <a:t>▸  註冊 → 登入 → 對話成功</a:t>
+            </a:r>
+            <a:endParaRPr lang="en-US" sz="1100" dirty="0"/>
+          </a:p>
+        </p:txBody>
+      </p:sp>
+      <p:sp>
+        <p:nvSpPr>
+          <p:cNvPr id="42" name="Shape 39"/>
           <p:cNvSpPr/>
           <p:nvPr/>
         </p:nvSpPr>
@@ -4922,14 +5390,14 @@
             <a:avLst/>
           </a:prstGeom>
           <a:solidFill>
-            <a:srgbClr val="1E2761"/>
+            <a:srgbClr val="8B5CF6"/>
           </a:solidFill>
           <a:ln/>
         </p:spPr>
       </p:sp>
       <p:sp>
         <p:nvSpPr>
-          <p:cNvPr id="31" name="Text 28"/>
+          <p:cNvPr id="43" name="Text 40"/>
           <p:cNvSpPr/>
           <p:nvPr/>
         </p:nvSpPr>
@@ -4968,7 +5436,7 @@
       </p:sp>
       <p:sp>
         <p:nvSpPr>
-          <p:cNvPr id="32" name="Shape 29"/>
+          <p:cNvPr id="44" name="Shape 41"/>
           <p:cNvSpPr/>
           <p:nvPr/>
         </p:nvSpPr>
@@ -4988,7 +5456,7 @@
       </p:sp>
       <p:sp>
         <p:nvSpPr>
-          <p:cNvPr id="33" name="Shape 30"/>
+          <p:cNvPr id="45" name="Shape 42"/>
           <p:cNvSpPr/>
           <p:nvPr/>
         </p:nvSpPr>
@@ -5013,7 +5481,7 @@
       </p:sp>
       <p:sp>
         <p:nvSpPr>
-          <p:cNvPr id="34" name="Shape 31"/>
+          <p:cNvPr id="46" name="Shape 43"/>
           <p:cNvSpPr/>
           <p:nvPr/>
         </p:nvSpPr>
@@ -5026,14 +5494,14 @@
             <a:avLst/>
           </a:prstGeom>
           <a:solidFill>
-            <a:srgbClr val="F38020"/>
+            <a:srgbClr val="1E2761"/>
           </a:solidFill>
           <a:ln/>
         </p:spPr>
       </p:sp>
       <p:sp>
         <p:nvSpPr>
-          <p:cNvPr id="35" name="Text 32"/>
+          <p:cNvPr id="47" name="Text 44"/>
           <p:cNvSpPr/>
           <p:nvPr/>
         </p:nvSpPr>
@@ -5064,7 +5532,7 @@
                 <a:ea typeface="Calibri" pitchFamily="34" charset="-122"/>
                 <a:cs typeface="Calibri" pitchFamily="34" charset="-120"/>
               </a:rPr>
-              <a:t>Phase 4</a:t>
+              <a:t>階段 D</a:t>
             </a:r>
             <a:endParaRPr lang="en-US" sz="1400" dirty="0"/>
           </a:p>
@@ -5072,7 +5540,7 @@
       </p:sp>
       <p:sp>
         <p:nvSpPr>
-          <p:cNvPr id="36" name="Text 33"/>
+          <p:cNvPr id="48" name="Text 45"/>
           <p:cNvSpPr/>
           <p:nvPr/>
         </p:nvSpPr>
@@ -5111,7 +5579,7 @@
       </p:sp>
       <p:sp>
         <p:nvSpPr>
-          <p:cNvPr id="37" name="Text 34"/>
+          <p:cNvPr id="49" name="Text 46"/>
           <p:cNvSpPr/>
           <p:nvPr/>
         </p:nvSpPr>
@@ -5150,7 +5618,163 @@
       </p:sp>
       <p:sp>
         <p:nvSpPr>
-          <p:cNvPr id="38" name="Shape 35"/>
+          <p:cNvPr id="50" name="Text 47"/>
+          <p:cNvSpPr/>
+          <p:nvPr/>
+        </p:nvSpPr>
+        <p:spPr>
+          <a:xfrm>
+            <a:off x="9201150" y="2990088"/>
+            <a:ext cx="2393442" cy="548640"/>
+          </a:xfrm>
+          <a:prstGeom prst="rect">
+            <a:avLst/>
+          </a:prstGeom>
+          <a:noFill/>
+          <a:ln/>
+        </p:spPr>
+        <p:txBody>
+          <a:bodyPr wrap="square" rtlCol="0" anchor="ctr"/>
+          <a:lstStyle/>
+          <a:p>
+            <a:pPr indent="0" marL="0">
+              <a:buNone/>
+            </a:pPr>
+            <a:r>
+              <a:rPr lang="en-US" sz="1100" dirty="0">
+                <a:solidFill>
+                  <a:srgbClr val="444444"/>
+                </a:solidFill>
+                <a:latin typeface="微軟正黑體" pitchFamily="34" charset="0"/>
+                <a:ea typeface="微軟正黑體" pitchFamily="34" charset="-122"/>
+                <a:cs typeface="微軟正黑體" pitchFamily="34" charset="-120"/>
+              </a:rPr>
+              <a:t>▸  MCP 工具管理頁查看工具</a:t>
+            </a:r>
+            <a:endParaRPr lang="en-US" sz="1100" dirty="0"/>
+          </a:p>
+        </p:txBody>
+      </p:sp>
+      <p:sp>
+        <p:nvSpPr>
+          <p:cNvPr id="51" name="Text 48"/>
+          <p:cNvSpPr/>
+          <p:nvPr/>
+        </p:nvSpPr>
+        <p:spPr>
+          <a:xfrm>
+            <a:off x="9201150" y="3584448"/>
+            <a:ext cx="2393442" cy="548640"/>
+          </a:xfrm>
+          <a:prstGeom prst="rect">
+            <a:avLst/>
+          </a:prstGeom>
+          <a:noFill/>
+          <a:ln/>
+        </p:spPr>
+        <p:txBody>
+          <a:bodyPr wrap="square" rtlCol="0" anchor="ctr"/>
+          <a:lstStyle/>
+          <a:p>
+            <a:pPr indent="0" marL="0">
+              <a:buNone/>
+            </a:pPr>
+            <a:r>
+              <a:rPr lang="en-US" sz="1100" dirty="0">
+                <a:solidFill>
+                  <a:srgbClr val="444444"/>
+                </a:solidFill>
+                <a:latin typeface="微軟正黑體" pitchFamily="34" charset="0"/>
+                <a:ea typeface="微軟正黑體" pitchFamily="34" charset="-122"/>
+                <a:cs typeface="微軟正黑體" pitchFamily="34" charset="-120"/>
+              </a:rPr>
+              <a:t>▸  對話試問「查 Cloudflare R2 文件」</a:t>
+            </a:r>
+            <a:endParaRPr lang="en-US" sz="1100" dirty="0"/>
+          </a:p>
+        </p:txBody>
+      </p:sp>
+      <p:sp>
+        <p:nvSpPr>
+          <p:cNvPr id="52" name="Text 49"/>
+          <p:cNvSpPr/>
+          <p:nvPr/>
+        </p:nvSpPr>
+        <p:spPr>
+          <a:xfrm>
+            <a:off x="9201150" y="4178808"/>
+            <a:ext cx="2393442" cy="548640"/>
+          </a:xfrm>
+          <a:prstGeom prst="rect">
+            <a:avLst/>
+          </a:prstGeom>
+          <a:noFill/>
+          <a:ln/>
+        </p:spPr>
+        <p:txBody>
+          <a:bodyPr wrap="square" rtlCol="0" anchor="ctr"/>
+          <a:lstStyle/>
+          <a:p>
+            <a:pPr indent="0" marL="0">
+              <a:buNone/>
+            </a:pPr>
+            <a:r>
+              <a:rPr lang="en-US" sz="1100" dirty="0">
+                <a:solidFill>
+                  <a:srgbClr val="444444"/>
+                </a:solidFill>
+                <a:latin typeface="微軟正黑體" pitchFamily="34" charset="0"/>
+                <a:ea typeface="微軟正黑體" pitchFamily="34" charset="-122"/>
+                <a:cs typeface="微軟正黑體" pitchFamily="34" charset="-120"/>
+              </a:rPr>
+              <a:t>▸  AI 自動 routing 到 MCP</a:t>
+            </a:r>
+            <a:endParaRPr lang="en-US" sz="1100" dirty="0"/>
+          </a:p>
+        </p:txBody>
+      </p:sp>
+      <p:sp>
+        <p:nvSpPr>
+          <p:cNvPr id="53" name="Text 50"/>
+          <p:cNvSpPr/>
+          <p:nvPr/>
+        </p:nvSpPr>
+        <p:spPr>
+          <a:xfrm>
+            <a:off x="9201150" y="4773168"/>
+            <a:ext cx="2393442" cy="548640"/>
+          </a:xfrm>
+          <a:prstGeom prst="rect">
+            <a:avLst/>
+          </a:prstGeom>
+          <a:noFill/>
+          <a:ln/>
+        </p:spPr>
+        <p:txBody>
+          <a:bodyPr wrap="square" rtlCol="0" anchor="ctr"/>
+          <a:lstStyle/>
+          <a:p>
+            <a:pPr indent="0" marL="0">
+              <a:buNone/>
+            </a:pPr>
+            <a:r>
+              <a:rPr lang="en-US" sz="1100" dirty="0">
+                <a:solidFill>
+                  <a:srgbClr val="444444"/>
+                </a:solidFill>
+                <a:latin typeface="微軟正黑體" pitchFamily="34" charset="0"/>
+                <a:ea typeface="微軟正黑體" pitchFamily="34" charset="-122"/>
+                <a:cs typeface="微軟正黑體" pitchFamily="34" charset="-120"/>
+              </a:rPr>
+              <a:t>▸  看完整 agentic loop 過程</a:t>
+            </a:r>
+            <a:endParaRPr lang="en-US" sz="1100" dirty="0"/>
+          </a:p>
+        </p:txBody>
+      </p:sp>
+      <p:sp>
+        <p:nvSpPr>
+          <p:cNvPr id="54" name="Shape 51"/>
           <p:cNvSpPr/>
           <p:nvPr/>
         </p:nvSpPr>
@@ -5163,14 +5787,14 @@
             <a:avLst/>
           </a:prstGeom>
           <a:solidFill>
-            <a:srgbClr val="F38020"/>
+            <a:srgbClr val="1E2761"/>
           </a:solidFill>
           <a:ln/>
         </p:spPr>
       </p:sp>
       <p:sp>
         <p:nvSpPr>
-          <p:cNvPr id="39" name="Text 36"/>
+          <p:cNvPr id="55" name="Text 52"/>
           <p:cNvSpPr/>
           <p:nvPr/>
         </p:nvSpPr>
@@ -6557,7 +7181,7 @@
                 <a:ea typeface="微軟正黑體" pitchFamily="34" charset="-122"/>
                 <a:cs typeface="微軟正黑體" pitchFamily="34" charset="-120"/>
               </a:rPr>
-              <a:t>聯絡：service@leyun.cloud · +886-2-77220055 · www.leyun.cloud · 講師 victor@leyun.com.tw</a:t>
+              <a:t>聯絡：service@leyun.cloud · +886-2-77220055 · www.leyun.cloud · 講師 victor@leyun.cloud</a:t>
             </a:r>
             <a:endParaRPr lang="en-US" sz="1100" dirty="0"/>
           </a:p>
@@ -6933,7 +7557,7 @@
                 <a:ea typeface="微軟正黑體" pitchFamily="34" charset="-122"/>
                 <a:cs typeface="微軟正黑體" pitchFamily="34" charset="-120"/>
               </a:rPr>
-              <a:t>victor@leyun.com.tw</a:t>
+              <a:t>victor@leyun.cloud</a:t>
             </a:r>
             <a:endParaRPr lang="en-US" sz="1400" dirty="0"/>
           </a:p>

</xml_diff>